<commit_message>
chore: update Race Navi store assets and docs
</commit_message>
<xml_diff>
--- a/assets/モック.pptx
+++ b/assets/モック.pptx
@@ -8,8 +8,9 @@
     <p:sldId id="256" r:id="rId2"/>
     <p:sldId id="258" r:id="rId3"/>
     <p:sldId id="259" r:id="rId4"/>
-    <p:sldId id="257" r:id="rId5"/>
-    <p:sldId id="260" r:id="rId6"/>
+    <p:sldId id="261" r:id="rId5"/>
+    <p:sldId id="257" r:id="rId6"/>
+    <p:sldId id="260" r:id="rId7"/>
   </p:sldIdLst>
   <p:sldSz cx="12192000" cy="6858000"/>
   <p:notesSz cx="6858000" cy="9144000"/>
@@ -263,7 +264,7 @@
           <a:p>
             <a:fld id="{345B8F37-77C0-8845-AC52-CAF113CEA985}" type="datetimeFigureOut">
               <a:rPr kumimoji="1" lang="ja-JP" altLang="en-US" smtClean="0"/>
-              <a:t>2026/3/7</a:t>
+              <a:t>2026/3/17</a:t>
             </a:fld>
             <a:endParaRPr kumimoji="1" lang="ja-JP" altLang="en-US"/>
           </a:p>
@@ -493,7 +494,7 @@
           <a:p>
             <a:fld id="{345B8F37-77C0-8845-AC52-CAF113CEA985}" type="datetimeFigureOut">
               <a:rPr kumimoji="1" lang="ja-JP" altLang="en-US" smtClean="0"/>
-              <a:t>2026/3/7</a:t>
+              <a:t>2026/3/17</a:t>
             </a:fld>
             <a:endParaRPr kumimoji="1" lang="ja-JP" altLang="en-US"/>
           </a:p>
@@ -733,7 +734,7 @@
           <a:p>
             <a:fld id="{345B8F37-77C0-8845-AC52-CAF113CEA985}" type="datetimeFigureOut">
               <a:rPr kumimoji="1" lang="ja-JP" altLang="en-US" smtClean="0"/>
-              <a:t>2026/3/7</a:t>
+              <a:t>2026/3/17</a:t>
             </a:fld>
             <a:endParaRPr kumimoji="1" lang="ja-JP" altLang="en-US"/>
           </a:p>
@@ -963,7 +964,7 @@
           <a:p>
             <a:fld id="{345B8F37-77C0-8845-AC52-CAF113CEA985}" type="datetimeFigureOut">
               <a:rPr kumimoji="1" lang="ja-JP" altLang="en-US" smtClean="0"/>
-              <a:t>2026/3/7</a:t>
+              <a:t>2026/3/17</a:t>
             </a:fld>
             <a:endParaRPr kumimoji="1" lang="ja-JP" altLang="en-US"/>
           </a:p>
@@ -1238,7 +1239,7 @@
           <a:p>
             <a:fld id="{345B8F37-77C0-8845-AC52-CAF113CEA985}" type="datetimeFigureOut">
               <a:rPr kumimoji="1" lang="ja-JP" altLang="en-US" smtClean="0"/>
-              <a:t>2026/3/7</a:t>
+              <a:t>2026/3/17</a:t>
             </a:fld>
             <a:endParaRPr kumimoji="1" lang="ja-JP" altLang="en-US"/>
           </a:p>
@@ -1567,7 +1568,7 @@
           <a:p>
             <a:fld id="{345B8F37-77C0-8845-AC52-CAF113CEA985}" type="datetimeFigureOut">
               <a:rPr kumimoji="1" lang="ja-JP" altLang="en-US" smtClean="0"/>
-              <a:t>2026/3/7</a:t>
+              <a:t>2026/3/17</a:t>
             </a:fld>
             <a:endParaRPr kumimoji="1" lang="ja-JP" altLang="en-US"/>
           </a:p>
@@ -2043,7 +2044,7 @@
           <a:p>
             <a:fld id="{345B8F37-77C0-8845-AC52-CAF113CEA985}" type="datetimeFigureOut">
               <a:rPr kumimoji="1" lang="ja-JP" altLang="en-US" smtClean="0"/>
-              <a:t>2026/3/7</a:t>
+              <a:t>2026/3/17</a:t>
             </a:fld>
             <a:endParaRPr kumimoji="1" lang="ja-JP" altLang="en-US"/>
           </a:p>
@@ -2184,7 +2185,7 @@
           <a:p>
             <a:fld id="{345B8F37-77C0-8845-AC52-CAF113CEA985}" type="datetimeFigureOut">
               <a:rPr kumimoji="1" lang="ja-JP" altLang="en-US" smtClean="0"/>
-              <a:t>2026/3/7</a:t>
+              <a:t>2026/3/17</a:t>
             </a:fld>
             <a:endParaRPr kumimoji="1" lang="ja-JP" altLang="en-US"/>
           </a:p>
@@ -2297,7 +2298,7 @@
           <a:p>
             <a:fld id="{345B8F37-77C0-8845-AC52-CAF113CEA985}" type="datetimeFigureOut">
               <a:rPr kumimoji="1" lang="ja-JP" altLang="en-US" smtClean="0"/>
-              <a:t>2026/3/7</a:t>
+              <a:t>2026/3/17</a:t>
             </a:fld>
             <a:endParaRPr kumimoji="1" lang="ja-JP" altLang="en-US"/>
           </a:p>
@@ -2640,7 +2641,7 @@
           <a:p>
             <a:fld id="{345B8F37-77C0-8845-AC52-CAF113CEA985}" type="datetimeFigureOut">
               <a:rPr kumimoji="1" lang="ja-JP" altLang="en-US" smtClean="0"/>
-              <a:t>2026/3/7</a:t>
+              <a:t>2026/3/17</a:t>
             </a:fld>
             <a:endParaRPr kumimoji="1" lang="ja-JP" altLang="en-US"/>
           </a:p>
@@ -2928,7 +2929,7 @@
           <a:p>
             <a:fld id="{345B8F37-77C0-8845-AC52-CAF113CEA985}" type="datetimeFigureOut">
               <a:rPr kumimoji="1" lang="ja-JP" altLang="en-US" smtClean="0"/>
-              <a:t>2026/3/7</a:t>
+              <a:t>2026/3/17</a:t>
             </a:fld>
             <a:endParaRPr kumimoji="1" lang="ja-JP" altLang="en-US"/>
           </a:p>
@@ -3201,7 +3202,7 @@
           <a:p>
             <a:fld id="{345B8F37-77C0-8845-AC52-CAF113CEA985}" type="datetimeFigureOut">
               <a:rPr kumimoji="1" lang="ja-JP" altLang="en-US" smtClean="0"/>
-              <a:t>2026/3/7</a:t>
+              <a:t>2026/3/17</a:t>
             </a:fld>
             <a:endParaRPr kumimoji="1" lang="ja-JP" altLang="en-US"/>
           </a:p>
@@ -6777,6 +6778,880 @@
         <p:cNvPr id="1" name="">
           <a:extLst>
             <a:ext uri="{FF2B5EF4-FFF2-40B4-BE49-F238E27FC236}">
+              <a16:creationId xmlns:a16="http://schemas.microsoft.com/office/drawing/2014/main" id="{CE873BC7-B155-5945-A8D6-B5291CE06CC9}"/>
+            </a:ext>
+          </a:extLst>
+        </p:cNvPr>
+        <p:cNvGrpSpPr/>
+        <p:nvPr/>
+      </p:nvGrpSpPr>
+      <p:grpSpPr>
+        <a:xfrm>
+          <a:off x="0" y="0"/>
+          <a:ext cx="0" cy="0"/>
+          <a:chOff x="0" y="0"/>
+          <a:chExt cx="0" cy="0"/>
+        </a:xfrm>
+      </p:grpSpPr>
+      <p:sp>
+        <p:nvSpPr>
+          <p:cNvPr id="5" name="角丸四角形 4">
+            <a:extLst>
+              <a:ext uri="{FF2B5EF4-FFF2-40B4-BE49-F238E27FC236}">
+                <a16:creationId xmlns:a16="http://schemas.microsoft.com/office/drawing/2014/main" id="{0BF07D4A-1445-91C5-D114-EB3C140E53B2}"/>
+              </a:ext>
+            </a:extLst>
+          </p:cNvPr>
+          <p:cNvSpPr/>
+          <p:nvPr/>
+        </p:nvSpPr>
+        <p:spPr>
+          <a:xfrm>
+            <a:off x="3377215" y="3670141"/>
+            <a:ext cx="5437572" cy="1257905"/>
+          </a:xfrm>
+          <a:prstGeom prst="roundRect">
+            <a:avLst/>
+          </a:prstGeom>
+        </p:spPr>
+        <p:style>
+          <a:lnRef idx="2">
+            <a:schemeClr val="accent1">
+              <a:shade val="15000"/>
+            </a:schemeClr>
+          </a:lnRef>
+          <a:fillRef idx="1">
+            <a:schemeClr val="accent1"/>
+          </a:fillRef>
+          <a:effectRef idx="0">
+            <a:schemeClr val="accent1"/>
+          </a:effectRef>
+          <a:fontRef idx="minor">
+            <a:schemeClr val="lt1"/>
+          </a:fontRef>
+        </p:style>
+        <p:txBody>
+          <a:bodyPr rtlCol="0" anchor="ctr"/>
+          <a:lstStyle/>
+          <a:p>
+            <a:pPr algn="ctr"/>
+            <a:r>
+              <a:rPr kumimoji="1" lang="ja-JP" altLang="en-US" sz="3600"/>
+              <a:t>ちょい落とし</a:t>
+            </a:r>
+          </a:p>
+        </p:txBody>
+      </p:sp>
+      <p:sp>
+        <p:nvSpPr>
+          <p:cNvPr id="15" name="正方形/長方形 14">
+            <a:extLst>
+              <a:ext uri="{FF2B5EF4-FFF2-40B4-BE49-F238E27FC236}">
+                <a16:creationId xmlns:a16="http://schemas.microsoft.com/office/drawing/2014/main" id="{A3908183-E050-A44C-D37E-F7997EF667DF}"/>
+              </a:ext>
+            </a:extLst>
+          </p:cNvPr>
+          <p:cNvSpPr/>
+          <p:nvPr/>
+        </p:nvSpPr>
+        <p:spPr>
+          <a:xfrm rot="20707280" flipH="1">
+            <a:off x="3051380" y="3491706"/>
+            <a:ext cx="514745" cy="1558521"/>
+          </a:xfrm>
+          <a:prstGeom prst="rect">
+            <a:avLst/>
+          </a:prstGeom>
+          <a:solidFill>
+            <a:schemeClr val="bg1"/>
+          </a:solidFill>
+          <a:ln>
+            <a:noFill/>
+          </a:ln>
+        </p:spPr>
+        <p:style>
+          <a:lnRef idx="2">
+            <a:schemeClr val="accent1">
+              <a:shade val="15000"/>
+            </a:schemeClr>
+          </a:lnRef>
+          <a:fillRef idx="1">
+            <a:schemeClr val="accent1"/>
+          </a:fillRef>
+          <a:effectRef idx="0">
+            <a:schemeClr val="accent1"/>
+          </a:effectRef>
+          <a:fontRef idx="minor">
+            <a:schemeClr val="lt1"/>
+          </a:fontRef>
+        </p:style>
+        <p:txBody>
+          <a:bodyPr rtlCol="0" anchor="ctr"/>
+          <a:lstStyle/>
+          <a:p>
+            <a:pPr algn="ctr"/>
+            <a:endParaRPr kumimoji="1" lang="ja-JP" altLang="en-US"/>
+          </a:p>
+        </p:txBody>
+      </p:sp>
+      <p:sp>
+        <p:nvSpPr>
+          <p:cNvPr id="14" name="正方形/長方形 13">
+            <a:extLst>
+              <a:ext uri="{FF2B5EF4-FFF2-40B4-BE49-F238E27FC236}">
+                <a16:creationId xmlns:a16="http://schemas.microsoft.com/office/drawing/2014/main" id="{EB47FF6F-CC1C-9147-5373-06D029D428FA}"/>
+              </a:ext>
+            </a:extLst>
+          </p:cNvPr>
+          <p:cNvSpPr/>
+          <p:nvPr/>
+        </p:nvSpPr>
+        <p:spPr>
+          <a:xfrm rot="892720">
+            <a:off x="8603733" y="3687557"/>
+            <a:ext cx="514745" cy="1558521"/>
+          </a:xfrm>
+          <a:prstGeom prst="rect">
+            <a:avLst/>
+          </a:prstGeom>
+          <a:solidFill>
+            <a:schemeClr val="bg1"/>
+          </a:solidFill>
+          <a:ln>
+            <a:noFill/>
+          </a:ln>
+        </p:spPr>
+        <p:style>
+          <a:lnRef idx="2">
+            <a:schemeClr val="accent1">
+              <a:shade val="15000"/>
+            </a:schemeClr>
+          </a:lnRef>
+          <a:fillRef idx="1">
+            <a:schemeClr val="accent1"/>
+          </a:fillRef>
+          <a:effectRef idx="0">
+            <a:schemeClr val="accent1"/>
+          </a:effectRef>
+          <a:fontRef idx="minor">
+            <a:schemeClr val="lt1"/>
+          </a:fontRef>
+        </p:style>
+        <p:txBody>
+          <a:bodyPr rtlCol="0" anchor="ctr"/>
+          <a:lstStyle/>
+          <a:p>
+            <a:pPr algn="ctr"/>
+            <a:endParaRPr kumimoji="1" lang="ja-JP" altLang="en-US"/>
+          </a:p>
+        </p:txBody>
+      </p:sp>
+      <p:sp>
+        <p:nvSpPr>
+          <p:cNvPr id="13" name="ドーナツ 12">
+            <a:extLst>
+              <a:ext uri="{FF2B5EF4-FFF2-40B4-BE49-F238E27FC236}">
+                <a16:creationId xmlns:a16="http://schemas.microsoft.com/office/drawing/2014/main" id="{62A224AD-BD8F-9B4D-7398-FE0E9D09BE5D}"/>
+              </a:ext>
+            </a:extLst>
+          </p:cNvPr>
+          <p:cNvSpPr/>
+          <p:nvPr/>
+        </p:nvSpPr>
+        <p:spPr>
+          <a:xfrm>
+            <a:off x="3396000" y="900113"/>
+            <a:ext cx="5400000" cy="5400000"/>
+          </a:xfrm>
+          <a:prstGeom prst="donut">
+            <a:avLst>
+              <a:gd name="adj" fmla="val 1867"/>
+            </a:avLst>
+          </a:prstGeom>
+          <a:solidFill>
+            <a:schemeClr val="tx1">
+              <a:lumMod val="50000"/>
+              <a:lumOff val="50000"/>
+            </a:schemeClr>
+          </a:solidFill>
+        </p:spPr>
+        <p:style>
+          <a:lnRef idx="2">
+            <a:schemeClr val="accent1">
+              <a:shade val="15000"/>
+            </a:schemeClr>
+          </a:lnRef>
+          <a:fillRef idx="1">
+            <a:schemeClr val="accent1"/>
+          </a:fillRef>
+          <a:effectRef idx="0">
+            <a:schemeClr val="accent1"/>
+          </a:effectRef>
+          <a:fontRef idx="minor">
+            <a:schemeClr val="lt1"/>
+          </a:fontRef>
+        </p:style>
+        <p:txBody>
+          <a:bodyPr rtlCol="0" anchor="ctr"/>
+          <a:lstStyle/>
+          <a:p>
+            <a:pPr algn="ctr"/>
+            <a:endParaRPr kumimoji="1" lang="ja-JP" altLang="en-US">
+              <a:solidFill>
+                <a:schemeClr val="tx1"/>
+              </a:solidFill>
+            </a:endParaRPr>
+          </a:p>
+        </p:txBody>
+      </p:sp>
+      <p:cxnSp>
+        <p:nvCxnSpPr>
+          <p:cNvPr id="17" name="直線コネクタ 16">
+            <a:extLst>
+              <a:ext uri="{FF2B5EF4-FFF2-40B4-BE49-F238E27FC236}">
+                <a16:creationId xmlns:a16="http://schemas.microsoft.com/office/drawing/2014/main" id="{FB26DFE4-8F93-AAC6-0D1D-CC004A059A6E}"/>
+              </a:ext>
+            </a:extLst>
+          </p:cNvPr>
+          <p:cNvCxnSpPr>
+            <a:cxnSpLocks/>
+          </p:cNvCxnSpPr>
+          <p:nvPr/>
+        </p:nvCxnSpPr>
+        <p:spPr>
+          <a:xfrm>
+            <a:off x="6096000" y="337930"/>
+            <a:ext cx="0" cy="6520070"/>
+          </a:xfrm>
+          <a:prstGeom prst="line">
+            <a:avLst/>
+          </a:prstGeom>
+        </p:spPr>
+        <p:style>
+          <a:lnRef idx="2">
+            <a:schemeClr val="accent1"/>
+          </a:lnRef>
+          <a:fillRef idx="0">
+            <a:schemeClr val="accent1"/>
+          </a:fillRef>
+          <a:effectRef idx="1">
+            <a:schemeClr val="accent1"/>
+          </a:effectRef>
+          <a:fontRef idx="minor">
+            <a:schemeClr val="tx1"/>
+          </a:fontRef>
+        </p:style>
+      </p:cxnSp>
+      <p:cxnSp>
+        <p:nvCxnSpPr>
+          <p:cNvPr id="23" name="直線コネクタ 22">
+            <a:extLst>
+              <a:ext uri="{FF2B5EF4-FFF2-40B4-BE49-F238E27FC236}">
+                <a16:creationId xmlns:a16="http://schemas.microsoft.com/office/drawing/2014/main" id="{AA266C7B-4C8A-FFE6-0B7E-48A80271B372}"/>
+              </a:ext>
+            </a:extLst>
+          </p:cNvPr>
+          <p:cNvCxnSpPr>
+            <a:cxnSpLocks/>
+          </p:cNvCxnSpPr>
+          <p:nvPr/>
+        </p:nvCxnSpPr>
+        <p:spPr>
+          <a:xfrm>
+            <a:off x="2484783" y="3632211"/>
+            <a:ext cx="6957391" cy="27514"/>
+          </a:xfrm>
+          <a:prstGeom prst="line">
+            <a:avLst/>
+          </a:prstGeom>
+        </p:spPr>
+        <p:style>
+          <a:lnRef idx="2">
+            <a:schemeClr val="accent1"/>
+          </a:lnRef>
+          <a:fillRef idx="0">
+            <a:schemeClr val="accent1"/>
+          </a:fillRef>
+          <a:effectRef idx="1">
+            <a:schemeClr val="accent1"/>
+          </a:effectRef>
+          <a:fontRef idx="minor">
+            <a:schemeClr val="tx1"/>
+          </a:fontRef>
+        </p:style>
+      </p:cxnSp>
+      <p:sp>
+        <p:nvSpPr>
+          <p:cNvPr id="53" name="テキスト ボックス 52">
+            <a:extLst>
+              <a:ext uri="{FF2B5EF4-FFF2-40B4-BE49-F238E27FC236}">
+                <a16:creationId xmlns:a16="http://schemas.microsoft.com/office/drawing/2014/main" id="{B25F7B2F-198D-7ADC-20B8-211688A9E75F}"/>
+              </a:ext>
+            </a:extLst>
+          </p:cNvPr>
+          <p:cNvSpPr txBox="1"/>
+          <p:nvPr/>
+        </p:nvSpPr>
+        <p:spPr>
+          <a:xfrm>
+            <a:off x="8445904" y="4860375"/>
+            <a:ext cx="341760" cy="369332"/>
+          </a:xfrm>
+          <a:prstGeom prst="rect">
+            <a:avLst/>
+          </a:prstGeom>
+          <a:noFill/>
+        </p:spPr>
+        <p:txBody>
+          <a:bodyPr wrap="square" rtlCol="0">
+            <a:spAutoFit/>
+          </a:bodyPr>
+          <a:lstStyle/>
+          <a:p>
+            <a:r>
+              <a:rPr lang="en-US" altLang="ja-JP" dirty="0"/>
+              <a:t>E</a:t>
+            </a:r>
+            <a:endParaRPr kumimoji="1" lang="ja-JP" altLang="en-US"/>
+          </a:p>
+        </p:txBody>
+      </p:sp>
+      <p:sp>
+        <p:nvSpPr>
+          <p:cNvPr id="67" name="テキスト ボックス 66">
+            <a:extLst>
+              <a:ext uri="{FF2B5EF4-FFF2-40B4-BE49-F238E27FC236}">
+                <a16:creationId xmlns:a16="http://schemas.microsoft.com/office/drawing/2014/main" id="{128222A0-93CF-0E07-48C0-7BA62EE28740}"/>
+              </a:ext>
+            </a:extLst>
+          </p:cNvPr>
+          <p:cNvSpPr txBox="1"/>
+          <p:nvPr/>
+        </p:nvSpPr>
+        <p:spPr>
+          <a:xfrm>
+            <a:off x="3035454" y="3429000"/>
+            <a:ext cx="341760" cy="369332"/>
+          </a:xfrm>
+          <a:prstGeom prst="rect">
+            <a:avLst/>
+          </a:prstGeom>
+          <a:noFill/>
+        </p:spPr>
+        <p:txBody>
+          <a:bodyPr wrap="square" rtlCol="0">
+            <a:spAutoFit/>
+          </a:bodyPr>
+          <a:lstStyle/>
+          <a:p>
+            <a:r>
+              <a:rPr lang="en-US" altLang="ja-JP" dirty="0"/>
+              <a:t>J</a:t>
+            </a:r>
+            <a:endParaRPr kumimoji="1" lang="ja-JP" altLang="en-US"/>
+          </a:p>
+        </p:txBody>
+      </p:sp>
+      <p:sp>
+        <p:nvSpPr>
+          <p:cNvPr id="4" name="ハート 3">
+            <a:extLst>
+              <a:ext uri="{FF2B5EF4-FFF2-40B4-BE49-F238E27FC236}">
+                <a16:creationId xmlns:a16="http://schemas.microsoft.com/office/drawing/2014/main" id="{46778085-7288-9F99-EC97-0547C9BE1DA1}"/>
+              </a:ext>
+            </a:extLst>
+          </p:cNvPr>
+          <p:cNvSpPr/>
+          <p:nvPr/>
+        </p:nvSpPr>
+        <p:spPr>
+          <a:xfrm>
+            <a:off x="4629123" y="1421791"/>
+            <a:ext cx="488696" cy="432040"/>
+          </a:xfrm>
+          <a:prstGeom prst="heart">
+            <a:avLst/>
+          </a:prstGeom>
+          <a:solidFill>
+            <a:schemeClr val="accent3">
+              <a:lumMod val="40000"/>
+              <a:lumOff val="60000"/>
+            </a:schemeClr>
+          </a:solidFill>
+          <a:ln w="38100">
+            <a:solidFill>
+              <a:schemeClr val="accent6"/>
+            </a:solidFill>
+          </a:ln>
+        </p:spPr>
+        <p:style>
+          <a:lnRef idx="2">
+            <a:schemeClr val="accent1">
+              <a:shade val="15000"/>
+            </a:schemeClr>
+          </a:lnRef>
+          <a:fillRef idx="1">
+            <a:schemeClr val="accent1"/>
+          </a:fillRef>
+          <a:effectRef idx="0">
+            <a:schemeClr val="accent1"/>
+          </a:effectRef>
+          <a:fontRef idx="minor">
+            <a:schemeClr val="lt1"/>
+          </a:fontRef>
+        </p:style>
+        <p:txBody>
+          <a:bodyPr rtlCol="0" anchor="ctr"/>
+          <a:lstStyle/>
+          <a:p>
+            <a:pPr algn="ctr"/>
+            <a:endParaRPr kumimoji="1" lang="ja-JP" altLang="en-US"/>
+          </a:p>
+        </p:txBody>
+      </p:sp>
+      <p:sp>
+        <p:nvSpPr>
+          <p:cNvPr id="3" name="テキスト ボックス 2">
+            <a:extLst>
+              <a:ext uri="{FF2B5EF4-FFF2-40B4-BE49-F238E27FC236}">
+                <a16:creationId xmlns:a16="http://schemas.microsoft.com/office/drawing/2014/main" id="{32688C3F-584A-5139-AB71-751A443F9AFC}"/>
+              </a:ext>
+            </a:extLst>
+          </p:cNvPr>
+          <p:cNvSpPr txBox="1"/>
+          <p:nvPr/>
+        </p:nvSpPr>
+        <p:spPr>
+          <a:xfrm>
+            <a:off x="5278238" y="1405163"/>
+            <a:ext cx="800219" cy="523220"/>
+          </a:xfrm>
+          <a:prstGeom prst="rect">
+            <a:avLst/>
+          </a:prstGeom>
+          <a:noFill/>
+        </p:spPr>
+        <p:txBody>
+          <a:bodyPr wrap="none" rtlCol="0">
+            <a:spAutoFit/>
+          </a:bodyPr>
+          <a:lstStyle/>
+          <a:p>
+            <a:r>
+              <a:rPr kumimoji="1" lang="en-US" altLang="ja-JP" sz="2800" b="1" dirty="0"/>
+              <a:t>152</a:t>
+            </a:r>
+            <a:endParaRPr kumimoji="1" lang="ja-JP" altLang="en-US" sz="2800" b="1"/>
+          </a:p>
+        </p:txBody>
+      </p:sp>
+      <p:sp>
+        <p:nvSpPr>
+          <p:cNvPr id="9" name="テキスト ボックス 8">
+            <a:extLst>
+              <a:ext uri="{FF2B5EF4-FFF2-40B4-BE49-F238E27FC236}">
+                <a16:creationId xmlns:a16="http://schemas.microsoft.com/office/drawing/2014/main" id="{B61A3AA7-1EA2-2762-CCF5-C57E07124B4A}"/>
+              </a:ext>
+            </a:extLst>
+          </p:cNvPr>
+          <p:cNvSpPr txBox="1"/>
+          <p:nvPr/>
+        </p:nvSpPr>
+        <p:spPr>
+          <a:xfrm>
+            <a:off x="3794940" y="2523725"/>
+            <a:ext cx="1741182" cy="1015663"/>
+          </a:xfrm>
+          <a:prstGeom prst="rect">
+            <a:avLst/>
+          </a:prstGeom>
+          <a:noFill/>
+        </p:spPr>
+        <p:txBody>
+          <a:bodyPr wrap="none" rtlCol="0">
+            <a:spAutoFit/>
+          </a:bodyPr>
+          <a:lstStyle/>
+          <a:p>
+            <a:r>
+              <a:rPr lang="en-US" altLang="ja-JP" sz="6000" b="1" dirty="0"/>
+              <a:t>7:21</a:t>
+            </a:r>
+            <a:endParaRPr kumimoji="1" lang="ja-JP" altLang="en-US" sz="6000" b="1"/>
+          </a:p>
+        </p:txBody>
+      </p:sp>
+      <p:sp>
+        <p:nvSpPr>
+          <p:cNvPr id="10" name="テキスト ボックス 9">
+            <a:extLst>
+              <a:ext uri="{FF2B5EF4-FFF2-40B4-BE49-F238E27FC236}">
+                <a16:creationId xmlns:a16="http://schemas.microsoft.com/office/drawing/2014/main" id="{54154297-8BF4-191B-8AA3-6CC37DBBE63C}"/>
+              </a:ext>
+            </a:extLst>
+          </p:cNvPr>
+          <p:cNvSpPr txBox="1"/>
+          <p:nvPr/>
+        </p:nvSpPr>
+        <p:spPr>
+          <a:xfrm>
+            <a:off x="5328010" y="2915600"/>
+            <a:ext cx="793807" cy="461665"/>
+          </a:xfrm>
+          <a:prstGeom prst="rect">
+            <a:avLst/>
+          </a:prstGeom>
+          <a:noFill/>
+        </p:spPr>
+        <p:txBody>
+          <a:bodyPr wrap="none" rtlCol="0">
+            <a:spAutoFit/>
+          </a:bodyPr>
+          <a:lstStyle/>
+          <a:p>
+            <a:r>
+              <a:rPr lang="en-US" altLang="ja-JP" sz="2400" b="1" dirty="0"/>
+              <a:t>/km</a:t>
+            </a:r>
+            <a:endParaRPr kumimoji="1" lang="ja-JP" altLang="en-US" sz="2400" b="1"/>
+          </a:p>
+        </p:txBody>
+      </p:sp>
+      <p:sp>
+        <p:nvSpPr>
+          <p:cNvPr id="11" name="テキスト ボックス 10">
+            <a:extLst>
+              <a:ext uri="{FF2B5EF4-FFF2-40B4-BE49-F238E27FC236}">
+                <a16:creationId xmlns:a16="http://schemas.microsoft.com/office/drawing/2014/main" id="{B296222B-B502-546B-F6A0-BC1247669732}"/>
+              </a:ext>
+            </a:extLst>
+          </p:cNvPr>
+          <p:cNvSpPr txBox="1"/>
+          <p:nvPr/>
+        </p:nvSpPr>
+        <p:spPr>
+          <a:xfrm>
+            <a:off x="4789542" y="4911165"/>
+            <a:ext cx="2590774" cy="461665"/>
+          </a:xfrm>
+          <a:prstGeom prst="rect">
+            <a:avLst/>
+          </a:prstGeom>
+          <a:noFill/>
+        </p:spPr>
+        <p:txBody>
+          <a:bodyPr wrap="none" rtlCol="0">
+            <a:spAutoFit/>
+          </a:bodyPr>
+          <a:lstStyle/>
+          <a:p>
+            <a:r>
+              <a:rPr lang="en-US" altLang="ja-JP" sz="2400" b="1" dirty="0"/>
+              <a:t>22.3 km </a:t>
+            </a:r>
+            <a:r>
+              <a:rPr kumimoji="1" lang="en-US" altLang="ja-JP" sz="2400" b="1" dirty="0"/>
+              <a:t> 2:33:12</a:t>
+            </a:r>
+            <a:endParaRPr kumimoji="1" lang="ja-JP" altLang="en-US" sz="2400" b="1"/>
+          </a:p>
+        </p:txBody>
+      </p:sp>
+      <p:sp>
+        <p:nvSpPr>
+          <p:cNvPr id="12" name="テキスト ボックス 11">
+            <a:extLst>
+              <a:ext uri="{FF2B5EF4-FFF2-40B4-BE49-F238E27FC236}">
+                <a16:creationId xmlns:a16="http://schemas.microsoft.com/office/drawing/2014/main" id="{F83BD3FD-4801-A03B-4991-AC5A2A544DD0}"/>
+              </a:ext>
+            </a:extLst>
+          </p:cNvPr>
+          <p:cNvSpPr txBox="1"/>
+          <p:nvPr/>
+        </p:nvSpPr>
+        <p:spPr>
+          <a:xfrm>
+            <a:off x="4962588" y="5383247"/>
+            <a:ext cx="2507418" cy="461665"/>
+          </a:xfrm>
+          <a:prstGeom prst="rect">
+            <a:avLst/>
+          </a:prstGeom>
+          <a:noFill/>
+        </p:spPr>
+        <p:txBody>
+          <a:bodyPr wrap="none" rtlCol="0">
+            <a:spAutoFit/>
+          </a:bodyPr>
+          <a:lstStyle/>
+          <a:p>
+            <a:r>
+              <a:rPr lang="en-US" altLang="ja-JP" sz="2400" b="1" dirty="0"/>
+              <a:t>4:00 (10</a:t>
+            </a:r>
+            <a:r>
+              <a:rPr lang="ja-JP" altLang="en-US" sz="2400" b="1"/>
+              <a:t>分遅れ</a:t>
+            </a:r>
+            <a:r>
+              <a:rPr lang="en-US" altLang="ja-JP" sz="2400" b="1" dirty="0"/>
+              <a:t>)</a:t>
+            </a:r>
+            <a:endParaRPr kumimoji="1" lang="ja-JP" altLang="en-US" sz="2400" b="1"/>
+          </a:p>
+        </p:txBody>
+      </p:sp>
+      <p:cxnSp>
+        <p:nvCxnSpPr>
+          <p:cNvPr id="20" name="直線コネクタ 19">
+            <a:extLst>
+              <a:ext uri="{FF2B5EF4-FFF2-40B4-BE49-F238E27FC236}">
+                <a16:creationId xmlns:a16="http://schemas.microsoft.com/office/drawing/2014/main" id="{F2924154-A299-C775-AA47-B4C0C93EB38C}"/>
+              </a:ext>
+            </a:extLst>
+          </p:cNvPr>
+          <p:cNvCxnSpPr>
+            <a:cxnSpLocks/>
+          </p:cNvCxnSpPr>
+          <p:nvPr/>
+        </p:nvCxnSpPr>
+        <p:spPr>
+          <a:xfrm>
+            <a:off x="2508456" y="4878722"/>
+            <a:ext cx="6957391" cy="27514"/>
+          </a:xfrm>
+          <a:prstGeom prst="line">
+            <a:avLst/>
+          </a:prstGeom>
+        </p:spPr>
+        <p:style>
+          <a:lnRef idx="2">
+            <a:schemeClr val="accent1"/>
+          </a:lnRef>
+          <a:fillRef idx="0">
+            <a:schemeClr val="accent1"/>
+          </a:fillRef>
+          <a:effectRef idx="1">
+            <a:schemeClr val="accent1"/>
+          </a:effectRef>
+          <a:fontRef idx="minor">
+            <a:schemeClr val="tx1"/>
+          </a:fontRef>
+        </p:style>
+      </p:cxnSp>
+      <p:cxnSp>
+        <p:nvCxnSpPr>
+          <p:cNvPr id="21" name="直線コネクタ 20">
+            <a:extLst>
+              <a:ext uri="{FF2B5EF4-FFF2-40B4-BE49-F238E27FC236}">
+                <a16:creationId xmlns:a16="http://schemas.microsoft.com/office/drawing/2014/main" id="{CB03671C-2BEB-1E2C-99D2-2E3001D92C20}"/>
+              </a:ext>
+            </a:extLst>
+          </p:cNvPr>
+          <p:cNvCxnSpPr>
+            <a:cxnSpLocks/>
+          </p:cNvCxnSpPr>
+          <p:nvPr/>
+        </p:nvCxnSpPr>
+        <p:spPr>
+          <a:xfrm>
+            <a:off x="2617304" y="2212297"/>
+            <a:ext cx="6957391" cy="27514"/>
+          </a:xfrm>
+          <a:prstGeom prst="line">
+            <a:avLst/>
+          </a:prstGeom>
+        </p:spPr>
+        <p:style>
+          <a:lnRef idx="2">
+            <a:schemeClr val="accent1"/>
+          </a:lnRef>
+          <a:fillRef idx="0">
+            <a:schemeClr val="accent1"/>
+          </a:fillRef>
+          <a:effectRef idx="1">
+            <a:schemeClr val="accent1"/>
+          </a:effectRef>
+          <a:fontRef idx="minor">
+            <a:schemeClr val="tx1"/>
+          </a:fontRef>
+        </p:style>
+      </p:cxnSp>
+      <p:sp>
+        <p:nvSpPr>
+          <p:cNvPr id="2" name="円/楕円 1">
+            <a:extLst>
+              <a:ext uri="{FF2B5EF4-FFF2-40B4-BE49-F238E27FC236}">
+                <a16:creationId xmlns:a16="http://schemas.microsoft.com/office/drawing/2014/main" id="{17DE3608-E7BC-AD4B-FEE8-571818311E1A}"/>
+              </a:ext>
+            </a:extLst>
+          </p:cNvPr>
+          <p:cNvSpPr>
+            <a:spLocks noChangeAspect="1"/>
+          </p:cNvSpPr>
+          <p:nvPr/>
+        </p:nvSpPr>
+        <p:spPr>
+          <a:xfrm>
+            <a:off x="6133352" y="1488502"/>
+            <a:ext cx="2052000" cy="2052000"/>
+          </a:xfrm>
+          <a:prstGeom prst="ellipse">
+            <a:avLst/>
+          </a:prstGeom>
+        </p:spPr>
+        <p:style>
+          <a:lnRef idx="2">
+            <a:schemeClr val="accent1">
+              <a:shade val="15000"/>
+            </a:schemeClr>
+          </a:lnRef>
+          <a:fillRef idx="1">
+            <a:schemeClr val="accent1"/>
+          </a:fillRef>
+          <a:effectRef idx="0">
+            <a:schemeClr val="accent1"/>
+          </a:effectRef>
+          <a:fontRef idx="minor">
+            <a:schemeClr val="lt1"/>
+          </a:fontRef>
+        </p:style>
+        <p:txBody>
+          <a:bodyPr rtlCol="0" anchor="ctr"/>
+          <a:lstStyle/>
+          <a:p>
+            <a:pPr algn="ctr"/>
+            <a:r>
+              <a:rPr kumimoji="1" lang="en-US" altLang="ja-JP" sz="2400" dirty="0"/>
+              <a:t>FUEL</a:t>
+            </a:r>
+          </a:p>
+          <a:p>
+            <a:pPr algn="ctr"/>
+            <a:r>
+              <a:rPr kumimoji="1" lang="en-US" altLang="ja-JP" sz="3600" dirty="0"/>
+              <a:t>6:20</a:t>
+            </a:r>
+            <a:endParaRPr kumimoji="1" lang="ja-JP" altLang="en-US" sz="3600"/>
+          </a:p>
+        </p:txBody>
+      </p:sp>
+      <p:sp>
+        <p:nvSpPr>
+          <p:cNvPr id="6" name="テキスト ボックス 5">
+            <a:extLst>
+              <a:ext uri="{FF2B5EF4-FFF2-40B4-BE49-F238E27FC236}">
+                <a16:creationId xmlns:a16="http://schemas.microsoft.com/office/drawing/2014/main" id="{9587620D-A034-6C2D-3078-2A5BDBBC6713}"/>
+              </a:ext>
+            </a:extLst>
+          </p:cNvPr>
+          <p:cNvSpPr txBox="1"/>
+          <p:nvPr/>
+        </p:nvSpPr>
+        <p:spPr>
+          <a:xfrm>
+            <a:off x="4927046" y="1926380"/>
+            <a:ext cx="1051891" cy="369332"/>
+          </a:xfrm>
+          <a:prstGeom prst="rect">
+            <a:avLst/>
+          </a:prstGeom>
+          <a:noFill/>
+        </p:spPr>
+        <p:txBody>
+          <a:bodyPr wrap="none" rtlCol="0">
+            <a:spAutoFit/>
+          </a:bodyPr>
+          <a:lstStyle/>
+          <a:p>
+            <a:r>
+              <a:rPr kumimoji="1" lang="en-US" altLang="ja-JP" b="1" dirty="0"/>
+              <a:t>cap 155</a:t>
+            </a:r>
+            <a:endParaRPr kumimoji="1" lang="ja-JP" altLang="en-US" b="1"/>
+          </a:p>
+        </p:txBody>
+      </p:sp>
+      <p:sp>
+        <p:nvSpPr>
+          <p:cNvPr id="16" name="正方形/長方形 15">
+            <a:extLst>
+              <a:ext uri="{FF2B5EF4-FFF2-40B4-BE49-F238E27FC236}">
+                <a16:creationId xmlns:a16="http://schemas.microsoft.com/office/drawing/2014/main" id="{E79528FF-4331-8A5C-9B71-802CFC5ADAEB}"/>
+              </a:ext>
+            </a:extLst>
+          </p:cNvPr>
+          <p:cNvSpPr/>
+          <p:nvPr/>
+        </p:nvSpPr>
+        <p:spPr>
+          <a:xfrm>
+            <a:off x="3935896" y="3798332"/>
+            <a:ext cx="4286807" cy="941783"/>
+          </a:xfrm>
+          <a:prstGeom prst="rect">
+            <a:avLst/>
+          </a:prstGeom>
+          <a:solidFill>
+            <a:schemeClr val="bg1"/>
+          </a:solidFill>
+          <a:ln>
+            <a:noFill/>
+          </a:ln>
+        </p:spPr>
+        <p:style>
+          <a:lnRef idx="2">
+            <a:schemeClr val="accent1">
+              <a:shade val="15000"/>
+            </a:schemeClr>
+          </a:lnRef>
+          <a:fillRef idx="1">
+            <a:schemeClr val="accent1"/>
+          </a:fillRef>
+          <a:effectRef idx="0">
+            <a:schemeClr val="accent1"/>
+          </a:effectRef>
+          <a:fontRef idx="minor">
+            <a:schemeClr val="lt1"/>
+          </a:fontRef>
+        </p:style>
+        <p:txBody>
+          <a:bodyPr rtlCol="0" anchor="ctr"/>
+          <a:lstStyle/>
+          <a:p>
+            <a:pPr algn="ctr"/>
+            <a:r>
+              <a:rPr kumimoji="1" lang="ja-JP" altLang="en-US" sz="4400" b="1">
+                <a:solidFill>
+                  <a:sysClr val="windowText" lastClr="000000"/>
+                </a:solidFill>
+              </a:rPr>
+              <a:t>ちょい落とし</a:t>
+            </a:r>
+          </a:p>
+        </p:txBody>
+      </p:sp>
+    </p:spTree>
+    <p:extLst>
+      <p:ext uri="{BB962C8B-B14F-4D97-AF65-F5344CB8AC3E}">
+        <p14:creationId xmlns:p14="http://schemas.microsoft.com/office/powerpoint/2010/main" val="1298994921"/>
+      </p:ext>
+    </p:extLst>
+  </p:cSld>
+  <p:clrMapOvr>
+    <a:masterClrMapping/>
+  </p:clrMapOvr>
+</p:sld>
+</file>
+
+<file path=ppt/slides/slide5.xml><?xml version="1.0" encoding="utf-8"?>
+<p:sld xmlns:a="http://schemas.openxmlformats.org/drawingml/2006/main" xmlns:r="http://schemas.openxmlformats.org/officeDocument/2006/relationships" xmlns:p="http://schemas.openxmlformats.org/presentationml/2006/main">
+  <p:cSld>
+    <p:spTree>
+      <p:nvGrpSpPr>
+        <p:cNvPr id="1" name="">
+          <a:extLst>
+            <a:ext uri="{FF2B5EF4-FFF2-40B4-BE49-F238E27FC236}">
               <a16:creationId xmlns:a16="http://schemas.microsoft.com/office/drawing/2014/main" id="{4A524312-2542-49DA-8C8F-C2544B5EAD8C}"/>
             </a:ext>
           </a:extLst>
@@ -7764,7 +8639,7 @@
 </p:sld>
 </file>
 
-<file path=ppt/slides/slide5.xml><?xml version="1.0" encoding="utf-8"?>
+<file path=ppt/slides/slide6.xml><?xml version="1.0" encoding="utf-8"?>
 <p:sld xmlns:a="http://schemas.openxmlformats.org/drawingml/2006/main" xmlns:r="http://schemas.openxmlformats.org/officeDocument/2006/relationships" xmlns:p="http://schemas.openxmlformats.org/presentationml/2006/main">
   <p:cSld>
     <p:spTree>

</xml_diff>

<commit_message>
chore: update Race Navi store assets and docs (#105)
</commit_message>
<xml_diff>
--- a/assets/モック.pptx
+++ b/assets/モック.pptx
@@ -8,8 +8,9 @@
     <p:sldId id="256" r:id="rId2"/>
     <p:sldId id="258" r:id="rId3"/>
     <p:sldId id="259" r:id="rId4"/>
-    <p:sldId id="257" r:id="rId5"/>
-    <p:sldId id="260" r:id="rId6"/>
+    <p:sldId id="261" r:id="rId5"/>
+    <p:sldId id="257" r:id="rId6"/>
+    <p:sldId id="260" r:id="rId7"/>
   </p:sldIdLst>
   <p:sldSz cx="12192000" cy="6858000"/>
   <p:notesSz cx="6858000" cy="9144000"/>
@@ -263,7 +264,7 @@
           <a:p>
             <a:fld id="{345B8F37-77C0-8845-AC52-CAF113CEA985}" type="datetimeFigureOut">
               <a:rPr kumimoji="1" lang="ja-JP" altLang="en-US" smtClean="0"/>
-              <a:t>2026/3/7</a:t>
+              <a:t>2026/3/17</a:t>
             </a:fld>
             <a:endParaRPr kumimoji="1" lang="ja-JP" altLang="en-US"/>
           </a:p>
@@ -493,7 +494,7 @@
           <a:p>
             <a:fld id="{345B8F37-77C0-8845-AC52-CAF113CEA985}" type="datetimeFigureOut">
               <a:rPr kumimoji="1" lang="ja-JP" altLang="en-US" smtClean="0"/>
-              <a:t>2026/3/7</a:t>
+              <a:t>2026/3/17</a:t>
             </a:fld>
             <a:endParaRPr kumimoji="1" lang="ja-JP" altLang="en-US"/>
           </a:p>
@@ -733,7 +734,7 @@
           <a:p>
             <a:fld id="{345B8F37-77C0-8845-AC52-CAF113CEA985}" type="datetimeFigureOut">
               <a:rPr kumimoji="1" lang="ja-JP" altLang="en-US" smtClean="0"/>
-              <a:t>2026/3/7</a:t>
+              <a:t>2026/3/17</a:t>
             </a:fld>
             <a:endParaRPr kumimoji="1" lang="ja-JP" altLang="en-US"/>
           </a:p>
@@ -963,7 +964,7 @@
           <a:p>
             <a:fld id="{345B8F37-77C0-8845-AC52-CAF113CEA985}" type="datetimeFigureOut">
               <a:rPr kumimoji="1" lang="ja-JP" altLang="en-US" smtClean="0"/>
-              <a:t>2026/3/7</a:t>
+              <a:t>2026/3/17</a:t>
             </a:fld>
             <a:endParaRPr kumimoji="1" lang="ja-JP" altLang="en-US"/>
           </a:p>
@@ -1238,7 +1239,7 @@
           <a:p>
             <a:fld id="{345B8F37-77C0-8845-AC52-CAF113CEA985}" type="datetimeFigureOut">
               <a:rPr kumimoji="1" lang="ja-JP" altLang="en-US" smtClean="0"/>
-              <a:t>2026/3/7</a:t>
+              <a:t>2026/3/17</a:t>
             </a:fld>
             <a:endParaRPr kumimoji="1" lang="ja-JP" altLang="en-US"/>
           </a:p>
@@ -1567,7 +1568,7 @@
           <a:p>
             <a:fld id="{345B8F37-77C0-8845-AC52-CAF113CEA985}" type="datetimeFigureOut">
               <a:rPr kumimoji="1" lang="ja-JP" altLang="en-US" smtClean="0"/>
-              <a:t>2026/3/7</a:t>
+              <a:t>2026/3/17</a:t>
             </a:fld>
             <a:endParaRPr kumimoji="1" lang="ja-JP" altLang="en-US"/>
           </a:p>
@@ -2043,7 +2044,7 @@
           <a:p>
             <a:fld id="{345B8F37-77C0-8845-AC52-CAF113CEA985}" type="datetimeFigureOut">
               <a:rPr kumimoji="1" lang="ja-JP" altLang="en-US" smtClean="0"/>
-              <a:t>2026/3/7</a:t>
+              <a:t>2026/3/17</a:t>
             </a:fld>
             <a:endParaRPr kumimoji="1" lang="ja-JP" altLang="en-US"/>
           </a:p>
@@ -2184,7 +2185,7 @@
           <a:p>
             <a:fld id="{345B8F37-77C0-8845-AC52-CAF113CEA985}" type="datetimeFigureOut">
               <a:rPr kumimoji="1" lang="ja-JP" altLang="en-US" smtClean="0"/>
-              <a:t>2026/3/7</a:t>
+              <a:t>2026/3/17</a:t>
             </a:fld>
             <a:endParaRPr kumimoji="1" lang="ja-JP" altLang="en-US"/>
           </a:p>
@@ -2297,7 +2298,7 @@
           <a:p>
             <a:fld id="{345B8F37-77C0-8845-AC52-CAF113CEA985}" type="datetimeFigureOut">
               <a:rPr kumimoji="1" lang="ja-JP" altLang="en-US" smtClean="0"/>
-              <a:t>2026/3/7</a:t>
+              <a:t>2026/3/17</a:t>
             </a:fld>
             <a:endParaRPr kumimoji="1" lang="ja-JP" altLang="en-US"/>
           </a:p>
@@ -2640,7 +2641,7 @@
           <a:p>
             <a:fld id="{345B8F37-77C0-8845-AC52-CAF113CEA985}" type="datetimeFigureOut">
               <a:rPr kumimoji="1" lang="ja-JP" altLang="en-US" smtClean="0"/>
-              <a:t>2026/3/7</a:t>
+              <a:t>2026/3/17</a:t>
             </a:fld>
             <a:endParaRPr kumimoji="1" lang="ja-JP" altLang="en-US"/>
           </a:p>
@@ -2928,7 +2929,7 @@
           <a:p>
             <a:fld id="{345B8F37-77C0-8845-AC52-CAF113CEA985}" type="datetimeFigureOut">
               <a:rPr kumimoji="1" lang="ja-JP" altLang="en-US" smtClean="0"/>
-              <a:t>2026/3/7</a:t>
+              <a:t>2026/3/17</a:t>
             </a:fld>
             <a:endParaRPr kumimoji="1" lang="ja-JP" altLang="en-US"/>
           </a:p>
@@ -3201,7 +3202,7 @@
           <a:p>
             <a:fld id="{345B8F37-77C0-8845-AC52-CAF113CEA985}" type="datetimeFigureOut">
               <a:rPr kumimoji="1" lang="ja-JP" altLang="en-US" smtClean="0"/>
-              <a:t>2026/3/7</a:t>
+              <a:t>2026/3/17</a:t>
             </a:fld>
             <a:endParaRPr kumimoji="1" lang="ja-JP" altLang="en-US"/>
           </a:p>
@@ -6777,6 +6778,880 @@
         <p:cNvPr id="1" name="">
           <a:extLst>
             <a:ext uri="{FF2B5EF4-FFF2-40B4-BE49-F238E27FC236}">
+              <a16:creationId xmlns:a16="http://schemas.microsoft.com/office/drawing/2014/main" id="{CE873BC7-B155-5945-A8D6-B5291CE06CC9}"/>
+            </a:ext>
+          </a:extLst>
+        </p:cNvPr>
+        <p:cNvGrpSpPr/>
+        <p:nvPr/>
+      </p:nvGrpSpPr>
+      <p:grpSpPr>
+        <a:xfrm>
+          <a:off x="0" y="0"/>
+          <a:ext cx="0" cy="0"/>
+          <a:chOff x="0" y="0"/>
+          <a:chExt cx="0" cy="0"/>
+        </a:xfrm>
+      </p:grpSpPr>
+      <p:sp>
+        <p:nvSpPr>
+          <p:cNvPr id="5" name="角丸四角形 4">
+            <a:extLst>
+              <a:ext uri="{FF2B5EF4-FFF2-40B4-BE49-F238E27FC236}">
+                <a16:creationId xmlns:a16="http://schemas.microsoft.com/office/drawing/2014/main" id="{0BF07D4A-1445-91C5-D114-EB3C140E53B2}"/>
+              </a:ext>
+            </a:extLst>
+          </p:cNvPr>
+          <p:cNvSpPr/>
+          <p:nvPr/>
+        </p:nvSpPr>
+        <p:spPr>
+          <a:xfrm>
+            <a:off x="3377215" y="3670141"/>
+            <a:ext cx="5437572" cy="1257905"/>
+          </a:xfrm>
+          <a:prstGeom prst="roundRect">
+            <a:avLst/>
+          </a:prstGeom>
+        </p:spPr>
+        <p:style>
+          <a:lnRef idx="2">
+            <a:schemeClr val="accent1">
+              <a:shade val="15000"/>
+            </a:schemeClr>
+          </a:lnRef>
+          <a:fillRef idx="1">
+            <a:schemeClr val="accent1"/>
+          </a:fillRef>
+          <a:effectRef idx="0">
+            <a:schemeClr val="accent1"/>
+          </a:effectRef>
+          <a:fontRef idx="minor">
+            <a:schemeClr val="lt1"/>
+          </a:fontRef>
+        </p:style>
+        <p:txBody>
+          <a:bodyPr rtlCol="0" anchor="ctr"/>
+          <a:lstStyle/>
+          <a:p>
+            <a:pPr algn="ctr"/>
+            <a:r>
+              <a:rPr kumimoji="1" lang="ja-JP" altLang="en-US" sz="3600"/>
+              <a:t>ちょい落とし</a:t>
+            </a:r>
+          </a:p>
+        </p:txBody>
+      </p:sp>
+      <p:sp>
+        <p:nvSpPr>
+          <p:cNvPr id="15" name="正方形/長方形 14">
+            <a:extLst>
+              <a:ext uri="{FF2B5EF4-FFF2-40B4-BE49-F238E27FC236}">
+                <a16:creationId xmlns:a16="http://schemas.microsoft.com/office/drawing/2014/main" id="{A3908183-E050-A44C-D37E-F7997EF667DF}"/>
+              </a:ext>
+            </a:extLst>
+          </p:cNvPr>
+          <p:cNvSpPr/>
+          <p:nvPr/>
+        </p:nvSpPr>
+        <p:spPr>
+          <a:xfrm rot="20707280" flipH="1">
+            <a:off x="3051380" y="3491706"/>
+            <a:ext cx="514745" cy="1558521"/>
+          </a:xfrm>
+          <a:prstGeom prst="rect">
+            <a:avLst/>
+          </a:prstGeom>
+          <a:solidFill>
+            <a:schemeClr val="bg1"/>
+          </a:solidFill>
+          <a:ln>
+            <a:noFill/>
+          </a:ln>
+        </p:spPr>
+        <p:style>
+          <a:lnRef idx="2">
+            <a:schemeClr val="accent1">
+              <a:shade val="15000"/>
+            </a:schemeClr>
+          </a:lnRef>
+          <a:fillRef idx="1">
+            <a:schemeClr val="accent1"/>
+          </a:fillRef>
+          <a:effectRef idx="0">
+            <a:schemeClr val="accent1"/>
+          </a:effectRef>
+          <a:fontRef idx="minor">
+            <a:schemeClr val="lt1"/>
+          </a:fontRef>
+        </p:style>
+        <p:txBody>
+          <a:bodyPr rtlCol="0" anchor="ctr"/>
+          <a:lstStyle/>
+          <a:p>
+            <a:pPr algn="ctr"/>
+            <a:endParaRPr kumimoji="1" lang="ja-JP" altLang="en-US"/>
+          </a:p>
+        </p:txBody>
+      </p:sp>
+      <p:sp>
+        <p:nvSpPr>
+          <p:cNvPr id="14" name="正方形/長方形 13">
+            <a:extLst>
+              <a:ext uri="{FF2B5EF4-FFF2-40B4-BE49-F238E27FC236}">
+                <a16:creationId xmlns:a16="http://schemas.microsoft.com/office/drawing/2014/main" id="{EB47FF6F-CC1C-9147-5373-06D029D428FA}"/>
+              </a:ext>
+            </a:extLst>
+          </p:cNvPr>
+          <p:cNvSpPr/>
+          <p:nvPr/>
+        </p:nvSpPr>
+        <p:spPr>
+          <a:xfrm rot="892720">
+            <a:off x="8603733" y="3687557"/>
+            <a:ext cx="514745" cy="1558521"/>
+          </a:xfrm>
+          <a:prstGeom prst="rect">
+            <a:avLst/>
+          </a:prstGeom>
+          <a:solidFill>
+            <a:schemeClr val="bg1"/>
+          </a:solidFill>
+          <a:ln>
+            <a:noFill/>
+          </a:ln>
+        </p:spPr>
+        <p:style>
+          <a:lnRef idx="2">
+            <a:schemeClr val="accent1">
+              <a:shade val="15000"/>
+            </a:schemeClr>
+          </a:lnRef>
+          <a:fillRef idx="1">
+            <a:schemeClr val="accent1"/>
+          </a:fillRef>
+          <a:effectRef idx="0">
+            <a:schemeClr val="accent1"/>
+          </a:effectRef>
+          <a:fontRef idx="minor">
+            <a:schemeClr val="lt1"/>
+          </a:fontRef>
+        </p:style>
+        <p:txBody>
+          <a:bodyPr rtlCol="0" anchor="ctr"/>
+          <a:lstStyle/>
+          <a:p>
+            <a:pPr algn="ctr"/>
+            <a:endParaRPr kumimoji="1" lang="ja-JP" altLang="en-US"/>
+          </a:p>
+        </p:txBody>
+      </p:sp>
+      <p:sp>
+        <p:nvSpPr>
+          <p:cNvPr id="13" name="ドーナツ 12">
+            <a:extLst>
+              <a:ext uri="{FF2B5EF4-FFF2-40B4-BE49-F238E27FC236}">
+                <a16:creationId xmlns:a16="http://schemas.microsoft.com/office/drawing/2014/main" id="{62A224AD-BD8F-9B4D-7398-FE0E9D09BE5D}"/>
+              </a:ext>
+            </a:extLst>
+          </p:cNvPr>
+          <p:cNvSpPr/>
+          <p:nvPr/>
+        </p:nvSpPr>
+        <p:spPr>
+          <a:xfrm>
+            <a:off x="3396000" y="900113"/>
+            <a:ext cx="5400000" cy="5400000"/>
+          </a:xfrm>
+          <a:prstGeom prst="donut">
+            <a:avLst>
+              <a:gd name="adj" fmla="val 1867"/>
+            </a:avLst>
+          </a:prstGeom>
+          <a:solidFill>
+            <a:schemeClr val="tx1">
+              <a:lumMod val="50000"/>
+              <a:lumOff val="50000"/>
+            </a:schemeClr>
+          </a:solidFill>
+        </p:spPr>
+        <p:style>
+          <a:lnRef idx="2">
+            <a:schemeClr val="accent1">
+              <a:shade val="15000"/>
+            </a:schemeClr>
+          </a:lnRef>
+          <a:fillRef idx="1">
+            <a:schemeClr val="accent1"/>
+          </a:fillRef>
+          <a:effectRef idx="0">
+            <a:schemeClr val="accent1"/>
+          </a:effectRef>
+          <a:fontRef idx="minor">
+            <a:schemeClr val="lt1"/>
+          </a:fontRef>
+        </p:style>
+        <p:txBody>
+          <a:bodyPr rtlCol="0" anchor="ctr"/>
+          <a:lstStyle/>
+          <a:p>
+            <a:pPr algn="ctr"/>
+            <a:endParaRPr kumimoji="1" lang="ja-JP" altLang="en-US">
+              <a:solidFill>
+                <a:schemeClr val="tx1"/>
+              </a:solidFill>
+            </a:endParaRPr>
+          </a:p>
+        </p:txBody>
+      </p:sp>
+      <p:cxnSp>
+        <p:nvCxnSpPr>
+          <p:cNvPr id="17" name="直線コネクタ 16">
+            <a:extLst>
+              <a:ext uri="{FF2B5EF4-FFF2-40B4-BE49-F238E27FC236}">
+                <a16:creationId xmlns:a16="http://schemas.microsoft.com/office/drawing/2014/main" id="{FB26DFE4-8F93-AAC6-0D1D-CC004A059A6E}"/>
+              </a:ext>
+            </a:extLst>
+          </p:cNvPr>
+          <p:cNvCxnSpPr>
+            <a:cxnSpLocks/>
+          </p:cNvCxnSpPr>
+          <p:nvPr/>
+        </p:nvCxnSpPr>
+        <p:spPr>
+          <a:xfrm>
+            <a:off x="6096000" y="337930"/>
+            <a:ext cx="0" cy="6520070"/>
+          </a:xfrm>
+          <a:prstGeom prst="line">
+            <a:avLst/>
+          </a:prstGeom>
+        </p:spPr>
+        <p:style>
+          <a:lnRef idx="2">
+            <a:schemeClr val="accent1"/>
+          </a:lnRef>
+          <a:fillRef idx="0">
+            <a:schemeClr val="accent1"/>
+          </a:fillRef>
+          <a:effectRef idx="1">
+            <a:schemeClr val="accent1"/>
+          </a:effectRef>
+          <a:fontRef idx="minor">
+            <a:schemeClr val="tx1"/>
+          </a:fontRef>
+        </p:style>
+      </p:cxnSp>
+      <p:cxnSp>
+        <p:nvCxnSpPr>
+          <p:cNvPr id="23" name="直線コネクタ 22">
+            <a:extLst>
+              <a:ext uri="{FF2B5EF4-FFF2-40B4-BE49-F238E27FC236}">
+                <a16:creationId xmlns:a16="http://schemas.microsoft.com/office/drawing/2014/main" id="{AA266C7B-4C8A-FFE6-0B7E-48A80271B372}"/>
+              </a:ext>
+            </a:extLst>
+          </p:cNvPr>
+          <p:cNvCxnSpPr>
+            <a:cxnSpLocks/>
+          </p:cNvCxnSpPr>
+          <p:nvPr/>
+        </p:nvCxnSpPr>
+        <p:spPr>
+          <a:xfrm>
+            <a:off x="2484783" y="3632211"/>
+            <a:ext cx="6957391" cy="27514"/>
+          </a:xfrm>
+          <a:prstGeom prst="line">
+            <a:avLst/>
+          </a:prstGeom>
+        </p:spPr>
+        <p:style>
+          <a:lnRef idx="2">
+            <a:schemeClr val="accent1"/>
+          </a:lnRef>
+          <a:fillRef idx="0">
+            <a:schemeClr val="accent1"/>
+          </a:fillRef>
+          <a:effectRef idx="1">
+            <a:schemeClr val="accent1"/>
+          </a:effectRef>
+          <a:fontRef idx="minor">
+            <a:schemeClr val="tx1"/>
+          </a:fontRef>
+        </p:style>
+      </p:cxnSp>
+      <p:sp>
+        <p:nvSpPr>
+          <p:cNvPr id="53" name="テキスト ボックス 52">
+            <a:extLst>
+              <a:ext uri="{FF2B5EF4-FFF2-40B4-BE49-F238E27FC236}">
+                <a16:creationId xmlns:a16="http://schemas.microsoft.com/office/drawing/2014/main" id="{B25F7B2F-198D-7ADC-20B8-211688A9E75F}"/>
+              </a:ext>
+            </a:extLst>
+          </p:cNvPr>
+          <p:cNvSpPr txBox="1"/>
+          <p:nvPr/>
+        </p:nvSpPr>
+        <p:spPr>
+          <a:xfrm>
+            <a:off x="8445904" y="4860375"/>
+            <a:ext cx="341760" cy="369332"/>
+          </a:xfrm>
+          <a:prstGeom prst="rect">
+            <a:avLst/>
+          </a:prstGeom>
+          <a:noFill/>
+        </p:spPr>
+        <p:txBody>
+          <a:bodyPr wrap="square" rtlCol="0">
+            <a:spAutoFit/>
+          </a:bodyPr>
+          <a:lstStyle/>
+          <a:p>
+            <a:r>
+              <a:rPr lang="en-US" altLang="ja-JP" dirty="0"/>
+              <a:t>E</a:t>
+            </a:r>
+            <a:endParaRPr kumimoji="1" lang="ja-JP" altLang="en-US"/>
+          </a:p>
+        </p:txBody>
+      </p:sp>
+      <p:sp>
+        <p:nvSpPr>
+          <p:cNvPr id="67" name="テキスト ボックス 66">
+            <a:extLst>
+              <a:ext uri="{FF2B5EF4-FFF2-40B4-BE49-F238E27FC236}">
+                <a16:creationId xmlns:a16="http://schemas.microsoft.com/office/drawing/2014/main" id="{128222A0-93CF-0E07-48C0-7BA62EE28740}"/>
+              </a:ext>
+            </a:extLst>
+          </p:cNvPr>
+          <p:cNvSpPr txBox="1"/>
+          <p:nvPr/>
+        </p:nvSpPr>
+        <p:spPr>
+          <a:xfrm>
+            <a:off x="3035454" y="3429000"/>
+            <a:ext cx="341760" cy="369332"/>
+          </a:xfrm>
+          <a:prstGeom prst="rect">
+            <a:avLst/>
+          </a:prstGeom>
+          <a:noFill/>
+        </p:spPr>
+        <p:txBody>
+          <a:bodyPr wrap="square" rtlCol="0">
+            <a:spAutoFit/>
+          </a:bodyPr>
+          <a:lstStyle/>
+          <a:p>
+            <a:r>
+              <a:rPr lang="en-US" altLang="ja-JP" dirty="0"/>
+              <a:t>J</a:t>
+            </a:r>
+            <a:endParaRPr kumimoji="1" lang="ja-JP" altLang="en-US"/>
+          </a:p>
+        </p:txBody>
+      </p:sp>
+      <p:sp>
+        <p:nvSpPr>
+          <p:cNvPr id="4" name="ハート 3">
+            <a:extLst>
+              <a:ext uri="{FF2B5EF4-FFF2-40B4-BE49-F238E27FC236}">
+                <a16:creationId xmlns:a16="http://schemas.microsoft.com/office/drawing/2014/main" id="{46778085-7288-9F99-EC97-0547C9BE1DA1}"/>
+              </a:ext>
+            </a:extLst>
+          </p:cNvPr>
+          <p:cNvSpPr/>
+          <p:nvPr/>
+        </p:nvSpPr>
+        <p:spPr>
+          <a:xfrm>
+            <a:off x="4629123" y="1421791"/>
+            <a:ext cx="488696" cy="432040"/>
+          </a:xfrm>
+          <a:prstGeom prst="heart">
+            <a:avLst/>
+          </a:prstGeom>
+          <a:solidFill>
+            <a:schemeClr val="accent3">
+              <a:lumMod val="40000"/>
+              <a:lumOff val="60000"/>
+            </a:schemeClr>
+          </a:solidFill>
+          <a:ln w="38100">
+            <a:solidFill>
+              <a:schemeClr val="accent6"/>
+            </a:solidFill>
+          </a:ln>
+        </p:spPr>
+        <p:style>
+          <a:lnRef idx="2">
+            <a:schemeClr val="accent1">
+              <a:shade val="15000"/>
+            </a:schemeClr>
+          </a:lnRef>
+          <a:fillRef idx="1">
+            <a:schemeClr val="accent1"/>
+          </a:fillRef>
+          <a:effectRef idx="0">
+            <a:schemeClr val="accent1"/>
+          </a:effectRef>
+          <a:fontRef idx="minor">
+            <a:schemeClr val="lt1"/>
+          </a:fontRef>
+        </p:style>
+        <p:txBody>
+          <a:bodyPr rtlCol="0" anchor="ctr"/>
+          <a:lstStyle/>
+          <a:p>
+            <a:pPr algn="ctr"/>
+            <a:endParaRPr kumimoji="1" lang="ja-JP" altLang="en-US"/>
+          </a:p>
+        </p:txBody>
+      </p:sp>
+      <p:sp>
+        <p:nvSpPr>
+          <p:cNvPr id="3" name="テキスト ボックス 2">
+            <a:extLst>
+              <a:ext uri="{FF2B5EF4-FFF2-40B4-BE49-F238E27FC236}">
+                <a16:creationId xmlns:a16="http://schemas.microsoft.com/office/drawing/2014/main" id="{32688C3F-584A-5139-AB71-751A443F9AFC}"/>
+              </a:ext>
+            </a:extLst>
+          </p:cNvPr>
+          <p:cNvSpPr txBox="1"/>
+          <p:nvPr/>
+        </p:nvSpPr>
+        <p:spPr>
+          <a:xfrm>
+            <a:off x="5278238" y="1405163"/>
+            <a:ext cx="800219" cy="523220"/>
+          </a:xfrm>
+          <a:prstGeom prst="rect">
+            <a:avLst/>
+          </a:prstGeom>
+          <a:noFill/>
+        </p:spPr>
+        <p:txBody>
+          <a:bodyPr wrap="none" rtlCol="0">
+            <a:spAutoFit/>
+          </a:bodyPr>
+          <a:lstStyle/>
+          <a:p>
+            <a:r>
+              <a:rPr kumimoji="1" lang="en-US" altLang="ja-JP" sz="2800" b="1" dirty="0"/>
+              <a:t>152</a:t>
+            </a:r>
+            <a:endParaRPr kumimoji="1" lang="ja-JP" altLang="en-US" sz="2800" b="1"/>
+          </a:p>
+        </p:txBody>
+      </p:sp>
+      <p:sp>
+        <p:nvSpPr>
+          <p:cNvPr id="9" name="テキスト ボックス 8">
+            <a:extLst>
+              <a:ext uri="{FF2B5EF4-FFF2-40B4-BE49-F238E27FC236}">
+                <a16:creationId xmlns:a16="http://schemas.microsoft.com/office/drawing/2014/main" id="{B61A3AA7-1EA2-2762-CCF5-C57E07124B4A}"/>
+              </a:ext>
+            </a:extLst>
+          </p:cNvPr>
+          <p:cNvSpPr txBox="1"/>
+          <p:nvPr/>
+        </p:nvSpPr>
+        <p:spPr>
+          <a:xfrm>
+            <a:off x="3794940" y="2523725"/>
+            <a:ext cx="1741182" cy="1015663"/>
+          </a:xfrm>
+          <a:prstGeom prst="rect">
+            <a:avLst/>
+          </a:prstGeom>
+          <a:noFill/>
+        </p:spPr>
+        <p:txBody>
+          <a:bodyPr wrap="none" rtlCol="0">
+            <a:spAutoFit/>
+          </a:bodyPr>
+          <a:lstStyle/>
+          <a:p>
+            <a:r>
+              <a:rPr lang="en-US" altLang="ja-JP" sz="6000" b="1" dirty="0"/>
+              <a:t>7:21</a:t>
+            </a:r>
+            <a:endParaRPr kumimoji="1" lang="ja-JP" altLang="en-US" sz="6000" b="1"/>
+          </a:p>
+        </p:txBody>
+      </p:sp>
+      <p:sp>
+        <p:nvSpPr>
+          <p:cNvPr id="10" name="テキスト ボックス 9">
+            <a:extLst>
+              <a:ext uri="{FF2B5EF4-FFF2-40B4-BE49-F238E27FC236}">
+                <a16:creationId xmlns:a16="http://schemas.microsoft.com/office/drawing/2014/main" id="{54154297-8BF4-191B-8AA3-6CC37DBBE63C}"/>
+              </a:ext>
+            </a:extLst>
+          </p:cNvPr>
+          <p:cNvSpPr txBox="1"/>
+          <p:nvPr/>
+        </p:nvSpPr>
+        <p:spPr>
+          <a:xfrm>
+            <a:off x="5328010" y="2915600"/>
+            <a:ext cx="793807" cy="461665"/>
+          </a:xfrm>
+          <a:prstGeom prst="rect">
+            <a:avLst/>
+          </a:prstGeom>
+          <a:noFill/>
+        </p:spPr>
+        <p:txBody>
+          <a:bodyPr wrap="none" rtlCol="0">
+            <a:spAutoFit/>
+          </a:bodyPr>
+          <a:lstStyle/>
+          <a:p>
+            <a:r>
+              <a:rPr lang="en-US" altLang="ja-JP" sz="2400" b="1" dirty="0"/>
+              <a:t>/km</a:t>
+            </a:r>
+            <a:endParaRPr kumimoji="1" lang="ja-JP" altLang="en-US" sz="2400" b="1"/>
+          </a:p>
+        </p:txBody>
+      </p:sp>
+      <p:sp>
+        <p:nvSpPr>
+          <p:cNvPr id="11" name="テキスト ボックス 10">
+            <a:extLst>
+              <a:ext uri="{FF2B5EF4-FFF2-40B4-BE49-F238E27FC236}">
+                <a16:creationId xmlns:a16="http://schemas.microsoft.com/office/drawing/2014/main" id="{B296222B-B502-546B-F6A0-BC1247669732}"/>
+              </a:ext>
+            </a:extLst>
+          </p:cNvPr>
+          <p:cNvSpPr txBox="1"/>
+          <p:nvPr/>
+        </p:nvSpPr>
+        <p:spPr>
+          <a:xfrm>
+            <a:off x="4789542" y="4911165"/>
+            <a:ext cx="2590774" cy="461665"/>
+          </a:xfrm>
+          <a:prstGeom prst="rect">
+            <a:avLst/>
+          </a:prstGeom>
+          <a:noFill/>
+        </p:spPr>
+        <p:txBody>
+          <a:bodyPr wrap="none" rtlCol="0">
+            <a:spAutoFit/>
+          </a:bodyPr>
+          <a:lstStyle/>
+          <a:p>
+            <a:r>
+              <a:rPr lang="en-US" altLang="ja-JP" sz="2400" b="1" dirty="0"/>
+              <a:t>22.3 km </a:t>
+            </a:r>
+            <a:r>
+              <a:rPr kumimoji="1" lang="en-US" altLang="ja-JP" sz="2400" b="1" dirty="0"/>
+              <a:t> 2:33:12</a:t>
+            </a:r>
+            <a:endParaRPr kumimoji="1" lang="ja-JP" altLang="en-US" sz="2400" b="1"/>
+          </a:p>
+        </p:txBody>
+      </p:sp>
+      <p:sp>
+        <p:nvSpPr>
+          <p:cNvPr id="12" name="テキスト ボックス 11">
+            <a:extLst>
+              <a:ext uri="{FF2B5EF4-FFF2-40B4-BE49-F238E27FC236}">
+                <a16:creationId xmlns:a16="http://schemas.microsoft.com/office/drawing/2014/main" id="{F83BD3FD-4801-A03B-4991-AC5A2A544DD0}"/>
+              </a:ext>
+            </a:extLst>
+          </p:cNvPr>
+          <p:cNvSpPr txBox="1"/>
+          <p:nvPr/>
+        </p:nvSpPr>
+        <p:spPr>
+          <a:xfrm>
+            <a:off x="4962588" y="5383247"/>
+            <a:ext cx="2507418" cy="461665"/>
+          </a:xfrm>
+          <a:prstGeom prst="rect">
+            <a:avLst/>
+          </a:prstGeom>
+          <a:noFill/>
+        </p:spPr>
+        <p:txBody>
+          <a:bodyPr wrap="none" rtlCol="0">
+            <a:spAutoFit/>
+          </a:bodyPr>
+          <a:lstStyle/>
+          <a:p>
+            <a:r>
+              <a:rPr lang="en-US" altLang="ja-JP" sz="2400" b="1" dirty="0"/>
+              <a:t>4:00 (10</a:t>
+            </a:r>
+            <a:r>
+              <a:rPr lang="ja-JP" altLang="en-US" sz="2400" b="1"/>
+              <a:t>分遅れ</a:t>
+            </a:r>
+            <a:r>
+              <a:rPr lang="en-US" altLang="ja-JP" sz="2400" b="1" dirty="0"/>
+              <a:t>)</a:t>
+            </a:r>
+            <a:endParaRPr kumimoji="1" lang="ja-JP" altLang="en-US" sz="2400" b="1"/>
+          </a:p>
+        </p:txBody>
+      </p:sp>
+      <p:cxnSp>
+        <p:nvCxnSpPr>
+          <p:cNvPr id="20" name="直線コネクタ 19">
+            <a:extLst>
+              <a:ext uri="{FF2B5EF4-FFF2-40B4-BE49-F238E27FC236}">
+                <a16:creationId xmlns:a16="http://schemas.microsoft.com/office/drawing/2014/main" id="{F2924154-A299-C775-AA47-B4C0C93EB38C}"/>
+              </a:ext>
+            </a:extLst>
+          </p:cNvPr>
+          <p:cNvCxnSpPr>
+            <a:cxnSpLocks/>
+          </p:cNvCxnSpPr>
+          <p:nvPr/>
+        </p:nvCxnSpPr>
+        <p:spPr>
+          <a:xfrm>
+            <a:off x="2508456" y="4878722"/>
+            <a:ext cx="6957391" cy="27514"/>
+          </a:xfrm>
+          <a:prstGeom prst="line">
+            <a:avLst/>
+          </a:prstGeom>
+        </p:spPr>
+        <p:style>
+          <a:lnRef idx="2">
+            <a:schemeClr val="accent1"/>
+          </a:lnRef>
+          <a:fillRef idx="0">
+            <a:schemeClr val="accent1"/>
+          </a:fillRef>
+          <a:effectRef idx="1">
+            <a:schemeClr val="accent1"/>
+          </a:effectRef>
+          <a:fontRef idx="minor">
+            <a:schemeClr val="tx1"/>
+          </a:fontRef>
+        </p:style>
+      </p:cxnSp>
+      <p:cxnSp>
+        <p:nvCxnSpPr>
+          <p:cNvPr id="21" name="直線コネクタ 20">
+            <a:extLst>
+              <a:ext uri="{FF2B5EF4-FFF2-40B4-BE49-F238E27FC236}">
+                <a16:creationId xmlns:a16="http://schemas.microsoft.com/office/drawing/2014/main" id="{CB03671C-2BEB-1E2C-99D2-2E3001D92C20}"/>
+              </a:ext>
+            </a:extLst>
+          </p:cNvPr>
+          <p:cNvCxnSpPr>
+            <a:cxnSpLocks/>
+          </p:cNvCxnSpPr>
+          <p:nvPr/>
+        </p:nvCxnSpPr>
+        <p:spPr>
+          <a:xfrm>
+            <a:off x="2617304" y="2212297"/>
+            <a:ext cx="6957391" cy="27514"/>
+          </a:xfrm>
+          <a:prstGeom prst="line">
+            <a:avLst/>
+          </a:prstGeom>
+        </p:spPr>
+        <p:style>
+          <a:lnRef idx="2">
+            <a:schemeClr val="accent1"/>
+          </a:lnRef>
+          <a:fillRef idx="0">
+            <a:schemeClr val="accent1"/>
+          </a:fillRef>
+          <a:effectRef idx="1">
+            <a:schemeClr val="accent1"/>
+          </a:effectRef>
+          <a:fontRef idx="minor">
+            <a:schemeClr val="tx1"/>
+          </a:fontRef>
+        </p:style>
+      </p:cxnSp>
+      <p:sp>
+        <p:nvSpPr>
+          <p:cNvPr id="2" name="円/楕円 1">
+            <a:extLst>
+              <a:ext uri="{FF2B5EF4-FFF2-40B4-BE49-F238E27FC236}">
+                <a16:creationId xmlns:a16="http://schemas.microsoft.com/office/drawing/2014/main" id="{17DE3608-E7BC-AD4B-FEE8-571818311E1A}"/>
+              </a:ext>
+            </a:extLst>
+          </p:cNvPr>
+          <p:cNvSpPr>
+            <a:spLocks noChangeAspect="1"/>
+          </p:cNvSpPr>
+          <p:nvPr/>
+        </p:nvSpPr>
+        <p:spPr>
+          <a:xfrm>
+            <a:off x="6133352" y="1488502"/>
+            <a:ext cx="2052000" cy="2052000"/>
+          </a:xfrm>
+          <a:prstGeom prst="ellipse">
+            <a:avLst/>
+          </a:prstGeom>
+        </p:spPr>
+        <p:style>
+          <a:lnRef idx="2">
+            <a:schemeClr val="accent1">
+              <a:shade val="15000"/>
+            </a:schemeClr>
+          </a:lnRef>
+          <a:fillRef idx="1">
+            <a:schemeClr val="accent1"/>
+          </a:fillRef>
+          <a:effectRef idx="0">
+            <a:schemeClr val="accent1"/>
+          </a:effectRef>
+          <a:fontRef idx="minor">
+            <a:schemeClr val="lt1"/>
+          </a:fontRef>
+        </p:style>
+        <p:txBody>
+          <a:bodyPr rtlCol="0" anchor="ctr"/>
+          <a:lstStyle/>
+          <a:p>
+            <a:pPr algn="ctr"/>
+            <a:r>
+              <a:rPr kumimoji="1" lang="en-US" altLang="ja-JP" sz="2400" dirty="0"/>
+              <a:t>FUEL</a:t>
+            </a:r>
+          </a:p>
+          <a:p>
+            <a:pPr algn="ctr"/>
+            <a:r>
+              <a:rPr kumimoji="1" lang="en-US" altLang="ja-JP" sz="3600" dirty="0"/>
+              <a:t>6:20</a:t>
+            </a:r>
+            <a:endParaRPr kumimoji="1" lang="ja-JP" altLang="en-US" sz="3600"/>
+          </a:p>
+        </p:txBody>
+      </p:sp>
+      <p:sp>
+        <p:nvSpPr>
+          <p:cNvPr id="6" name="テキスト ボックス 5">
+            <a:extLst>
+              <a:ext uri="{FF2B5EF4-FFF2-40B4-BE49-F238E27FC236}">
+                <a16:creationId xmlns:a16="http://schemas.microsoft.com/office/drawing/2014/main" id="{9587620D-A034-6C2D-3078-2A5BDBBC6713}"/>
+              </a:ext>
+            </a:extLst>
+          </p:cNvPr>
+          <p:cNvSpPr txBox="1"/>
+          <p:nvPr/>
+        </p:nvSpPr>
+        <p:spPr>
+          <a:xfrm>
+            <a:off x="4927046" y="1926380"/>
+            <a:ext cx="1051891" cy="369332"/>
+          </a:xfrm>
+          <a:prstGeom prst="rect">
+            <a:avLst/>
+          </a:prstGeom>
+          <a:noFill/>
+        </p:spPr>
+        <p:txBody>
+          <a:bodyPr wrap="none" rtlCol="0">
+            <a:spAutoFit/>
+          </a:bodyPr>
+          <a:lstStyle/>
+          <a:p>
+            <a:r>
+              <a:rPr kumimoji="1" lang="en-US" altLang="ja-JP" b="1" dirty="0"/>
+              <a:t>cap 155</a:t>
+            </a:r>
+            <a:endParaRPr kumimoji="1" lang="ja-JP" altLang="en-US" b="1"/>
+          </a:p>
+        </p:txBody>
+      </p:sp>
+      <p:sp>
+        <p:nvSpPr>
+          <p:cNvPr id="16" name="正方形/長方形 15">
+            <a:extLst>
+              <a:ext uri="{FF2B5EF4-FFF2-40B4-BE49-F238E27FC236}">
+                <a16:creationId xmlns:a16="http://schemas.microsoft.com/office/drawing/2014/main" id="{E79528FF-4331-8A5C-9B71-802CFC5ADAEB}"/>
+              </a:ext>
+            </a:extLst>
+          </p:cNvPr>
+          <p:cNvSpPr/>
+          <p:nvPr/>
+        </p:nvSpPr>
+        <p:spPr>
+          <a:xfrm>
+            <a:off x="3935896" y="3798332"/>
+            <a:ext cx="4286807" cy="941783"/>
+          </a:xfrm>
+          <a:prstGeom prst="rect">
+            <a:avLst/>
+          </a:prstGeom>
+          <a:solidFill>
+            <a:schemeClr val="bg1"/>
+          </a:solidFill>
+          <a:ln>
+            <a:noFill/>
+          </a:ln>
+        </p:spPr>
+        <p:style>
+          <a:lnRef idx="2">
+            <a:schemeClr val="accent1">
+              <a:shade val="15000"/>
+            </a:schemeClr>
+          </a:lnRef>
+          <a:fillRef idx="1">
+            <a:schemeClr val="accent1"/>
+          </a:fillRef>
+          <a:effectRef idx="0">
+            <a:schemeClr val="accent1"/>
+          </a:effectRef>
+          <a:fontRef idx="minor">
+            <a:schemeClr val="lt1"/>
+          </a:fontRef>
+        </p:style>
+        <p:txBody>
+          <a:bodyPr rtlCol="0" anchor="ctr"/>
+          <a:lstStyle/>
+          <a:p>
+            <a:pPr algn="ctr"/>
+            <a:r>
+              <a:rPr kumimoji="1" lang="ja-JP" altLang="en-US" sz="4400" b="1">
+                <a:solidFill>
+                  <a:sysClr val="windowText" lastClr="000000"/>
+                </a:solidFill>
+              </a:rPr>
+              <a:t>ちょい落とし</a:t>
+            </a:r>
+          </a:p>
+        </p:txBody>
+      </p:sp>
+    </p:spTree>
+    <p:extLst>
+      <p:ext uri="{BB962C8B-B14F-4D97-AF65-F5344CB8AC3E}">
+        <p14:creationId xmlns:p14="http://schemas.microsoft.com/office/powerpoint/2010/main" val="1298994921"/>
+      </p:ext>
+    </p:extLst>
+  </p:cSld>
+  <p:clrMapOvr>
+    <a:masterClrMapping/>
+  </p:clrMapOvr>
+</p:sld>
+</file>
+
+<file path=ppt/slides/slide5.xml><?xml version="1.0" encoding="utf-8"?>
+<p:sld xmlns:a="http://schemas.openxmlformats.org/drawingml/2006/main" xmlns:r="http://schemas.openxmlformats.org/officeDocument/2006/relationships" xmlns:p="http://schemas.openxmlformats.org/presentationml/2006/main">
+  <p:cSld>
+    <p:spTree>
+      <p:nvGrpSpPr>
+        <p:cNvPr id="1" name="">
+          <a:extLst>
+            <a:ext uri="{FF2B5EF4-FFF2-40B4-BE49-F238E27FC236}">
               <a16:creationId xmlns:a16="http://schemas.microsoft.com/office/drawing/2014/main" id="{4A524312-2542-49DA-8C8F-C2544B5EAD8C}"/>
             </a:ext>
           </a:extLst>
@@ -7764,7 +8639,7 @@
 </p:sld>
 </file>
 
-<file path=ppt/slides/slide5.xml><?xml version="1.0" encoding="utf-8"?>
+<file path=ppt/slides/slide6.xml><?xml version="1.0" encoding="utf-8"?>
 <p:sld xmlns:a="http://schemas.openxmlformats.org/drawingml/2006/main" xmlns:r="http://schemas.openxmlformats.org/officeDocument/2006/relationships" xmlns:p="http://schemas.openxmlformats.org/presentationml/2006/main">
   <p:cSld>
     <p:spTree>

</xml_diff>

<commit_message>
Merge remaining local changes
</commit_message>
<xml_diff>
--- a/assets/モック.pptx
+++ b/assets/モック.pptx
@@ -9,8 +9,9 @@
     <p:sldId id="258" r:id="rId3"/>
     <p:sldId id="259" r:id="rId4"/>
     <p:sldId id="261" r:id="rId5"/>
-    <p:sldId id="257" r:id="rId6"/>
-    <p:sldId id="260" r:id="rId7"/>
+    <p:sldId id="262" r:id="rId6"/>
+    <p:sldId id="257" r:id="rId7"/>
+    <p:sldId id="260" r:id="rId8"/>
   </p:sldIdLst>
   <p:sldSz cx="12192000" cy="6858000"/>
   <p:notesSz cx="6858000" cy="9144000"/>
@@ -264,7 +265,7 @@
           <a:p>
             <a:fld id="{345B8F37-77C0-8845-AC52-CAF113CEA985}" type="datetimeFigureOut">
               <a:rPr kumimoji="1" lang="ja-JP" altLang="en-US" smtClean="0"/>
-              <a:t>2026/3/17</a:t>
+              <a:t>2026/3/21</a:t>
             </a:fld>
             <a:endParaRPr kumimoji="1" lang="ja-JP" altLang="en-US"/>
           </a:p>
@@ -494,7 +495,7 @@
           <a:p>
             <a:fld id="{345B8F37-77C0-8845-AC52-CAF113CEA985}" type="datetimeFigureOut">
               <a:rPr kumimoji="1" lang="ja-JP" altLang="en-US" smtClean="0"/>
-              <a:t>2026/3/17</a:t>
+              <a:t>2026/3/21</a:t>
             </a:fld>
             <a:endParaRPr kumimoji="1" lang="ja-JP" altLang="en-US"/>
           </a:p>
@@ -734,7 +735,7 @@
           <a:p>
             <a:fld id="{345B8F37-77C0-8845-AC52-CAF113CEA985}" type="datetimeFigureOut">
               <a:rPr kumimoji="1" lang="ja-JP" altLang="en-US" smtClean="0"/>
-              <a:t>2026/3/17</a:t>
+              <a:t>2026/3/21</a:t>
             </a:fld>
             <a:endParaRPr kumimoji="1" lang="ja-JP" altLang="en-US"/>
           </a:p>
@@ -964,7 +965,7 @@
           <a:p>
             <a:fld id="{345B8F37-77C0-8845-AC52-CAF113CEA985}" type="datetimeFigureOut">
               <a:rPr kumimoji="1" lang="ja-JP" altLang="en-US" smtClean="0"/>
-              <a:t>2026/3/17</a:t>
+              <a:t>2026/3/21</a:t>
             </a:fld>
             <a:endParaRPr kumimoji="1" lang="ja-JP" altLang="en-US"/>
           </a:p>
@@ -1239,7 +1240,7 @@
           <a:p>
             <a:fld id="{345B8F37-77C0-8845-AC52-CAF113CEA985}" type="datetimeFigureOut">
               <a:rPr kumimoji="1" lang="ja-JP" altLang="en-US" smtClean="0"/>
-              <a:t>2026/3/17</a:t>
+              <a:t>2026/3/21</a:t>
             </a:fld>
             <a:endParaRPr kumimoji="1" lang="ja-JP" altLang="en-US"/>
           </a:p>
@@ -1568,7 +1569,7 @@
           <a:p>
             <a:fld id="{345B8F37-77C0-8845-AC52-CAF113CEA985}" type="datetimeFigureOut">
               <a:rPr kumimoji="1" lang="ja-JP" altLang="en-US" smtClean="0"/>
-              <a:t>2026/3/17</a:t>
+              <a:t>2026/3/21</a:t>
             </a:fld>
             <a:endParaRPr kumimoji="1" lang="ja-JP" altLang="en-US"/>
           </a:p>
@@ -2044,7 +2045,7 @@
           <a:p>
             <a:fld id="{345B8F37-77C0-8845-AC52-CAF113CEA985}" type="datetimeFigureOut">
               <a:rPr kumimoji="1" lang="ja-JP" altLang="en-US" smtClean="0"/>
-              <a:t>2026/3/17</a:t>
+              <a:t>2026/3/21</a:t>
             </a:fld>
             <a:endParaRPr kumimoji="1" lang="ja-JP" altLang="en-US"/>
           </a:p>
@@ -2185,7 +2186,7 @@
           <a:p>
             <a:fld id="{345B8F37-77C0-8845-AC52-CAF113CEA985}" type="datetimeFigureOut">
               <a:rPr kumimoji="1" lang="ja-JP" altLang="en-US" smtClean="0"/>
-              <a:t>2026/3/17</a:t>
+              <a:t>2026/3/21</a:t>
             </a:fld>
             <a:endParaRPr kumimoji="1" lang="ja-JP" altLang="en-US"/>
           </a:p>
@@ -2298,7 +2299,7 @@
           <a:p>
             <a:fld id="{345B8F37-77C0-8845-AC52-CAF113CEA985}" type="datetimeFigureOut">
               <a:rPr kumimoji="1" lang="ja-JP" altLang="en-US" smtClean="0"/>
-              <a:t>2026/3/17</a:t>
+              <a:t>2026/3/21</a:t>
             </a:fld>
             <a:endParaRPr kumimoji="1" lang="ja-JP" altLang="en-US"/>
           </a:p>
@@ -2641,7 +2642,7 @@
           <a:p>
             <a:fld id="{345B8F37-77C0-8845-AC52-CAF113CEA985}" type="datetimeFigureOut">
               <a:rPr kumimoji="1" lang="ja-JP" altLang="en-US" smtClean="0"/>
-              <a:t>2026/3/17</a:t>
+              <a:t>2026/3/21</a:t>
             </a:fld>
             <a:endParaRPr kumimoji="1" lang="ja-JP" altLang="en-US"/>
           </a:p>
@@ -2929,7 +2930,7 @@
           <a:p>
             <a:fld id="{345B8F37-77C0-8845-AC52-CAF113CEA985}" type="datetimeFigureOut">
               <a:rPr kumimoji="1" lang="ja-JP" altLang="en-US" smtClean="0"/>
-              <a:t>2026/3/17</a:t>
+              <a:t>2026/3/21</a:t>
             </a:fld>
             <a:endParaRPr kumimoji="1" lang="ja-JP" altLang="en-US"/>
           </a:p>
@@ -3202,7 +3203,7 @@
           <a:p>
             <a:fld id="{345B8F37-77C0-8845-AC52-CAF113CEA985}" type="datetimeFigureOut">
               <a:rPr kumimoji="1" lang="ja-JP" altLang="en-US" smtClean="0"/>
-              <a:t>2026/3/17</a:t>
+              <a:t>2026/3/21</a:t>
             </a:fld>
             <a:endParaRPr kumimoji="1" lang="ja-JP" altLang="en-US"/>
           </a:p>
@@ -7652,6 +7653,857 @@
         <p:cNvPr id="1" name="">
           <a:extLst>
             <a:ext uri="{FF2B5EF4-FFF2-40B4-BE49-F238E27FC236}">
+              <a16:creationId xmlns:a16="http://schemas.microsoft.com/office/drawing/2014/main" id="{5442CF35-9A69-9D1D-95EC-2EB9B1C6F105}"/>
+            </a:ext>
+          </a:extLst>
+        </p:cNvPr>
+        <p:cNvGrpSpPr/>
+        <p:nvPr/>
+      </p:nvGrpSpPr>
+      <p:grpSpPr>
+        <a:xfrm>
+          <a:off x="0" y="0"/>
+          <a:ext cx="0" cy="0"/>
+          <a:chOff x="0" y="0"/>
+          <a:chExt cx="0" cy="0"/>
+        </a:xfrm>
+      </p:grpSpPr>
+      <p:sp>
+        <p:nvSpPr>
+          <p:cNvPr id="5" name="角丸四角形 4">
+            <a:extLst>
+              <a:ext uri="{FF2B5EF4-FFF2-40B4-BE49-F238E27FC236}">
+                <a16:creationId xmlns:a16="http://schemas.microsoft.com/office/drawing/2014/main" id="{4A2A53C1-EB95-EF1F-4910-C5337F376400}"/>
+              </a:ext>
+            </a:extLst>
+          </p:cNvPr>
+          <p:cNvSpPr/>
+          <p:nvPr/>
+        </p:nvSpPr>
+        <p:spPr>
+          <a:xfrm>
+            <a:off x="3449223" y="2306383"/>
+            <a:ext cx="5437572" cy="1257905"/>
+          </a:xfrm>
+          <a:prstGeom prst="roundRect">
+            <a:avLst/>
+          </a:prstGeom>
+        </p:spPr>
+        <p:style>
+          <a:lnRef idx="2">
+            <a:schemeClr val="accent1">
+              <a:shade val="15000"/>
+            </a:schemeClr>
+          </a:lnRef>
+          <a:fillRef idx="1">
+            <a:schemeClr val="accent1"/>
+          </a:fillRef>
+          <a:effectRef idx="0">
+            <a:schemeClr val="accent1"/>
+          </a:effectRef>
+          <a:fontRef idx="minor">
+            <a:schemeClr val="lt1"/>
+          </a:fontRef>
+        </p:style>
+        <p:txBody>
+          <a:bodyPr rtlCol="0" anchor="ctr"/>
+          <a:lstStyle/>
+          <a:p>
+            <a:pPr algn="ctr"/>
+            <a:r>
+              <a:rPr kumimoji="1" lang="ja-JP" altLang="en-US" sz="3600"/>
+              <a:t>ちょい落とし</a:t>
+            </a:r>
+          </a:p>
+        </p:txBody>
+      </p:sp>
+      <p:sp>
+        <p:nvSpPr>
+          <p:cNvPr id="15" name="正方形/長方形 14">
+            <a:extLst>
+              <a:ext uri="{FF2B5EF4-FFF2-40B4-BE49-F238E27FC236}">
+                <a16:creationId xmlns:a16="http://schemas.microsoft.com/office/drawing/2014/main" id="{827ACAC7-D00E-6220-8A18-807EA52A9AD1}"/>
+              </a:ext>
+            </a:extLst>
+          </p:cNvPr>
+          <p:cNvSpPr/>
+          <p:nvPr/>
+        </p:nvSpPr>
+        <p:spPr>
+          <a:xfrm rot="892720" flipH="1" flipV="1">
+            <a:off x="3085015" y="1975482"/>
+            <a:ext cx="514745" cy="1558521"/>
+          </a:xfrm>
+          <a:prstGeom prst="rect">
+            <a:avLst/>
+          </a:prstGeom>
+          <a:solidFill>
+            <a:schemeClr val="bg1"/>
+          </a:solidFill>
+          <a:ln>
+            <a:noFill/>
+          </a:ln>
+        </p:spPr>
+        <p:style>
+          <a:lnRef idx="2">
+            <a:schemeClr val="accent1">
+              <a:shade val="15000"/>
+            </a:schemeClr>
+          </a:lnRef>
+          <a:fillRef idx="1">
+            <a:schemeClr val="accent1"/>
+          </a:fillRef>
+          <a:effectRef idx="0">
+            <a:schemeClr val="accent1"/>
+          </a:effectRef>
+          <a:fontRef idx="minor">
+            <a:schemeClr val="lt1"/>
+          </a:fontRef>
+        </p:style>
+        <p:txBody>
+          <a:bodyPr rtlCol="0" anchor="ctr"/>
+          <a:lstStyle/>
+          <a:p>
+            <a:pPr algn="ctr"/>
+            <a:endParaRPr kumimoji="1" lang="ja-JP" altLang="en-US"/>
+          </a:p>
+        </p:txBody>
+      </p:sp>
+      <p:sp>
+        <p:nvSpPr>
+          <p:cNvPr id="14" name="正方形/長方形 13">
+            <a:extLst>
+              <a:ext uri="{FF2B5EF4-FFF2-40B4-BE49-F238E27FC236}">
+                <a16:creationId xmlns:a16="http://schemas.microsoft.com/office/drawing/2014/main" id="{5CD8988F-7127-53B5-8BD3-D039C611CB38}"/>
+              </a:ext>
+            </a:extLst>
+          </p:cNvPr>
+          <p:cNvSpPr/>
+          <p:nvPr/>
+        </p:nvSpPr>
+        <p:spPr>
+          <a:xfrm rot="20707280" flipV="1">
+            <a:off x="8637368" y="2171333"/>
+            <a:ext cx="514745" cy="1558521"/>
+          </a:xfrm>
+          <a:prstGeom prst="rect">
+            <a:avLst/>
+          </a:prstGeom>
+          <a:solidFill>
+            <a:schemeClr val="bg1"/>
+          </a:solidFill>
+          <a:ln>
+            <a:noFill/>
+          </a:ln>
+        </p:spPr>
+        <p:style>
+          <a:lnRef idx="2">
+            <a:schemeClr val="accent1">
+              <a:shade val="15000"/>
+            </a:schemeClr>
+          </a:lnRef>
+          <a:fillRef idx="1">
+            <a:schemeClr val="accent1"/>
+          </a:fillRef>
+          <a:effectRef idx="0">
+            <a:schemeClr val="accent1"/>
+          </a:effectRef>
+          <a:fontRef idx="minor">
+            <a:schemeClr val="lt1"/>
+          </a:fontRef>
+        </p:style>
+        <p:txBody>
+          <a:bodyPr rtlCol="0" anchor="ctr"/>
+          <a:lstStyle/>
+          <a:p>
+            <a:pPr algn="ctr"/>
+            <a:endParaRPr kumimoji="1" lang="ja-JP" altLang="en-US"/>
+          </a:p>
+        </p:txBody>
+      </p:sp>
+      <p:sp>
+        <p:nvSpPr>
+          <p:cNvPr id="13" name="ドーナツ 12">
+            <a:extLst>
+              <a:ext uri="{FF2B5EF4-FFF2-40B4-BE49-F238E27FC236}">
+                <a16:creationId xmlns:a16="http://schemas.microsoft.com/office/drawing/2014/main" id="{7F47662C-2F13-872A-F810-7663FEFC6251}"/>
+              </a:ext>
+            </a:extLst>
+          </p:cNvPr>
+          <p:cNvSpPr/>
+          <p:nvPr/>
+        </p:nvSpPr>
+        <p:spPr>
+          <a:xfrm>
+            <a:off x="3396000" y="900113"/>
+            <a:ext cx="5400000" cy="5400000"/>
+          </a:xfrm>
+          <a:prstGeom prst="donut">
+            <a:avLst>
+              <a:gd name="adj" fmla="val 1867"/>
+            </a:avLst>
+          </a:prstGeom>
+          <a:solidFill>
+            <a:schemeClr val="tx1">
+              <a:lumMod val="50000"/>
+              <a:lumOff val="50000"/>
+            </a:schemeClr>
+          </a:solidFill>
+        </p:spPr>
+        <p:style>
+          <a:lnRef idx="2">
+            <a:schemeClr val="accent1">
+              <a:shade val="15000"/>
+            </a:schemeClr>
+          </a:lnRef>
+          <a:fillRef idx="1">
+            <a:schemeClr val="accent1"/>
+          </a:fillRef>
+          <a:effectRef idx="0">
+            <a:schemeClr val="accent1"/>
+          </a:effectRef>
+          <a:fontRef idx="minor">
+            <a:schemeClr val="lt1"/>
+          </a:fontRef>
+        </p:style>
+        <p:txBody>
+          <a:bodyPr rtlCol="0" anchor="ctr"/>
+          <a:lstStyle/>
+          <a:p>
+            <a:pPr algn="ctr"/>
+            <a:endParaRPr kumimoji="1" lang="ja-JP" altLang="en-US">
+              <a:solidFill>
+                <a:schemeClr val="tx1"/>
+              </a:solidFill>
+            </a:endParaRPr>
+          </a:p>
+        </p:txBody>
+      </p:sp>
+      <p:cxnSp>
+        <p:nvCxnSpPr>
+          <p:cNvPr id="17" name="直線コネクタ 16">
+            <a:extLst>
+              <a:ext uri="{FF2B5EF4-FFF2-40B4-BE49-F238E27FC236}">
+                <a16:creationId xmlns:a16="http://schemas.microsoft.com/office/drawing/2014/main" id="{26AF439D-4A39-CEFF-1CA7-7886D9C0CC51}"/>
+              </a:ext>
+            </a:extLst>
+          </p:cNvPr>
+          <p:cNvCxnSpPr>
+            <a:cxnSpLocks/>
+          </p:cNvCxnSpPr>
+          <p:nvPr/>
+        </p:nvCxnSpPr>
+        <p:spPr>
+          <a:xfrm>
+            <a:off x="6096000" y="337930"/>
+            <a:ext cx="0" cy="6520070"/>
+          </a:xfrm>
+          <a:prstGeom prst="line">
+            <a:avLst/>
+          </a:prstGeom>
+        </p:spPr>
+        <p:style>
+          <a:lnRef idx="2">
+            <a:schemeClr val="accent1"/>
+          </a:lnRef>
+          <a:fillRef idx="0">
+            <a:schemeClr val="accent1"/>
+          </a:fillRef>
+          <a:effectRef idx="1">
+            <a:schemeClr val="accent1"/>
+          </a:effectRef>
+          <a:fontRef idx="minor">
+            <a:schemeClr val="tx1"/>
+          </a:fontRef>
+        </p:style>
+      </p:cxnSp>
+      <p:cxnSp>
+        <p:nvCxnSpPr>
+          <p:cNvPr id="23" name="直線コネクタ 22">
+            <a:extLst>
+              <a:ext uri="{FF2B5EF4-FFF2-40B4-BE49-F238E27FC236}">
+                <a16:creationId xmlns:a16="http://schemas.microsoft.com/office/drawing/2014/main" id="{CD203221-8549-C002-E3D4-DAC3AD0830AA}"/>
+              </a:ext>
+            </a:extLst>
+          </p:cNvPr>
+          <p:cNvCxnSpPr>
+            <a:cxnSpLocks/>
+          </p:cNvCxnSpPr>
+          <p:nvPr/>
+        </p:nvCxnSpPr>
+        <p:spPr>
+          <a:xfrm>
+            <a:off x="2484783" y="3632211"/>
+            <a:ext cx="6957391" cy="27514"/>
+          </a:xfrm>
+          <a:prstGeom prst="line">
+            <a:avLst/>
+          </a:prstGeom>
+        </p:spPr>
+        <p:style>
+          <a:lnRef idx="2">
+            <a:schemeClr val="accent1"/>
+          </a:lnRef>
+          <a:fillRef idx="0">
+            <a:schemeClr val="accent1"/>
+          </a:fillRef>
+          <a:effectRef idx="1">
+            <a:schemeClr val="accent1"/>
+          </a:effectRef>
+          <a:fontRef idx="minor">
+            <a:schemeClr val="tx1"/>
+          </a:fontRef>
+        </p:style>
+      </p:cxnSp>
+      <p:sp>
+        <p:nvSpPr>
+          <p:cNvPr id="53" name="テキスト ボックス 52">
+            <a:extLst>
+              <a:ext uri="{FF2B5EF4-FFF2-40B4-BE49-F238E27FC236}">
+                <a16:creationId xmlns:a16="http://schemas.microsoft.com/office/drawing/2014/main" id="{72676624-449C-5992-F924-7AB1D3351774}"/>
+              </a:ext>
+            </a:extLst>
+          </p:cNvPr>
+          <p:cNvSpPr txBox="1"/>
+          <p:nvPr/>
+        </p:nvSpPr>
+        <p:spPr>
+          <a:xfrm>
+            <a:off x="8445904" y="4860375"/>
+            <a:ext cx="341760" cy="369332"/>
+          </a:xfrm>
+          <a:prstGeom prst="rect">
+            <a:avLst/>
+          </a:prstGeom>
+          <a:noFill/>
+        </p:spPr>
+        <p:txBody>
+          <a:bodyPr wrap="square" rtlCol="0">
+            <a:spAutoFit/>
+          </a:bodyPr>
+          <a:lstStyle/>
+          <a:p>
+            <a:r>
+              <a:rPr lang="en-US" altLang="ja-JP" dirty="0"/>
+              <a:t>E</a:t>
+            </a:r>
+            <a:endParaRPr kumimoji="1" lang="ja-JP" altLang="en-US"/>
+          </a:p>
+        </p:txBody>
+      </p:sp>
+      <p:sp>
+        <p:nvSpPr>
+          <p:cNvPr id="67" name="テキスト ボックス 66">
+            <a:extLst>
+              <a:ext uri="{FF2B5EF4-FFF2-40B4-BE49-F238E27FC236}">
+                <a16:creationId xmlns:a16="http://schemas.microsoft.com/office/drawing/2014/main" id="{E678C8CA-A4A9-E37D-69AE-8FB9B3AF3826}"/>
+              </a:ext>
+            </a:extLst>
+          </p:cNvPr>
+          <p:cNvSpPr txBox="1"/>
+          <p:nvPr/>
+        </p:nvSpPr>
+        <p:spPr>
+          <a:xfrm>
+            <a:off x="3035454" y="3429000"/>
+            <a:ext cx="341760" cy="369332"/>
+          </a:xfrm>
+          <a:prstGeom prst="rect">
+            <a:avLst/>
+          </a:prstGeom>
+          <a:noFill/>
+        </p:spPr>
+        <p:txBody>
+          <a:bodyPr wrap="square" rtlCol="0">
+            <a:spAutoFit/>
+          </a:bodyPr>
+          <a:lstStyle/>
+          <a:p>
+            <a:r>
+              <a:rPr lang="en-US" altLang="ja-JP" dirty="0"/>
+              <a:t>J</a:t>
+            </a:r>
+            <a:endParaRPr kumimoji="1" lang="ja-JP" altLang="en-US"/>
+          </a:p>
+        </p:txBody>
+      </p:sp>
+      <p:sp>
+        <p:nvSpPr>
+          <p:cNvPr id="4" name="ハート 3">
+            <a:extLst>
+              <a:ext uri="{FF2B5EF4-FFF2-40B4-BE49-F238E27FC236}">
+                <a16:creationId xmlns:a16="http://schemas.microsoft.com/office/drawing/2014/main" id="{EDBE5130-6299-5FC9-FB6C-F12B6D982EA6}"/>
+              </a:ext>
+            </a:extLst>
+          </p:cNvPr>
+          <p:cNvSpPr/>
+          <p:nvPr/>
+        </p:nvSpPr>
+        <p:spPr>
+          <a:xfrm>
+            <a:off x="4609003" y="1680371"/>
+            <a:ext cx="488696" cy="432040"/>
+          </a:xfrm>
+          <a:prstGeom prst="heart">
+            <a:avLst/>
+          </a:prstGeom>
+          <a:solidFill>
+            <a:schemeClr val="accent3">
+              <a:lumMod val="40000"/>
+              <a:lumOff val="60000"/>
+            </a:schemeClr>
+          </a:solidFill>
+          <a:ln w="38100">
+            <a:solidFill>
+              <a:schemeClr val="accent6"/>
+            </a:solidFill>
+          </a:ln>
+        </p:spPr>
+        <p:style>
+          <a:lnRef idx="2">
+            <a:schemeClr val="accent1">
+              <a:shade val="15000"/>
+            </a:schemeClr>
+          </a:lnRef>
+          <a:fillRef idx="1">
+            <a:schemeClr val="accent1"/>
+          </a:fillRef>
+          <a:effectRef idx="0">
+            <a:schemeClr val="accent1"/>
+          </a:effectRef>
+          <a:fontRef idx="minor">
+            <a:schemeClr val="lt1"/>
+          </a:fontRef>
+        </p:style>
+        <p:txBody>
+          <a:bodyPr rtlCol="0" anchor="ctr"/>
+          <a:lstStyle/>
+          <a:p>
+            <a:pPr algn="ctr"/>
+            <a:endParaRPr kumimoji="1" lang="ja-JP" altLang="en-US"/>
+          </a:p>
+        </p:txBody>
+      </p:sp>
+      <p:sp>
+        <p:nvSpPr>
+          <p:cNvPr id="3" name="テキスト ボックス 2">
+            <a:extLst>
+              <a:ext uri="{FF2B5EF4-FFF2-40B4-BE49-F238E27FC236}">
+                <a16:creationId xmlns:a16="http://schemas.microsoft.com/office/drawing/2014/main" id="{CB912C3D-A750-5FDC-9E75-929E81937DD2}"/>
+              </a:ext>
+            </a:extLst>
+          </p:cNvPr>
+          <p:cNvSpPr txBox="1"/>
+          <p:nvPr/>
+        </p:nvSpPr>
+        <p:spPr>
+          <a:xfrm>
+            <a:off x="5258118" y="1663743"/>
+            <a:ext cx="800219" cy="523220"/>
+          </a:xfrm>
+          <a:prstGeom prst="rect">
+            <a:avLst/>
+          </a:prstGeom>
+          <a:noFill/>
+        </p:spPr>
+        <p:txBody>
+          <a:bodyPr wrap="none" rtlCol="0">
+            <a:spAutoFit/>
+          </a:bodyPr>
+          <a:lstStyle/>
+          <a:p>
+            <a:r>
+              <a:rPr kumimoji="1" lang="en-US" altLang="ja-JP" sz="2800" b="1" dirty="0"/>
+              <a:t>152</a:t>
+            </a:r>
+            <a:endParaRPr kumimoji="1" lang="ja-JP" altLang="en-US" sz="2800" b="1"/>
+          </a:p>
+        </p:txBody>
+      </p:sp>
+      <p:sp>
+        <p:nvSpPr>
+          <p:cNvPr id="9" name="テキスト ボックス 8">
+            <a:extLst>
+              <a:ext uri="{FF2B5EF4-FFF2-40B4-BE49-F238E27FC236}">
+                <a16:creationId xmlns:a16="http://schemas.microsoft.com/office/drawing/2014/main" id="{74D9A41E-BCA6-00DB-FE9E-9C6741AD23EB}"/>
+              </a:ext>
+            </a:extLst>
+          </p:cNvPr>
+          <p:cNvSpPr txBox="1"/>
+          <p:nvPr/>
+        </p:nvSpPr>
+        <p:spPr>
+          <a:xfrm>
+            <a:off x="6151308" y="1434034"/>
+            <a:ext cx="1430200" cy="830997"/>
+          </a:xfrm>
+          <a:prstGeom prst="rect">
+            <a:avLst/>
+          </a:prstGeom>
+          <a:noFill/>
+        </p:spPr>
+        <p:txBody>
+          <a:bodyPr wrap="none" rtlCol="0">
+            <a:spAutoFit/>
+          </a:bodyPr>
+          <a:lstStyle/>
+          <a:p>
+            <a:r>
+              <a:rPr lang="en-US" altLang="ja-JP" sz="4800" b="1" dirty="0"/>
+              <a:t>7:21</a:t>
+            </a:r>
+            <a:endParaRPr kumimoji="1" lang="ja-JP" altLang="en-US" sz="4800" b="1"/>
+          </a:p>
+        </p:txBody>
+      </p:sp>
+      <p:sp>
+        <p:nvSpPr>
+          <p:cNvPr id="10" name="テキスト ボックス 9">
+            <a:extLst>
+              <a:ext uri="{FF2B5EF4-FFF2-40B4-BE49-F238E27FC236}">
+                <a16:creationId xmlns:a16="http://schemas.microsoft.com/office/drawing/2014/main" id="{58E1BB0C-B7AB-461D-2579-9663FBB8FB63}"/>
+              </a:ext>
+            </a:extLst>
+          </p:cNvPr>
+          <p:cNvSpPr txBox="1"/>
+          <p:nvPr/>
+        </p:nvSpPr>
+        <p:spPr>
+          <a:xfrm>
+            <a:off x="7394946" y="1762435"/>
+            <a:ext cx="793807" cy="461665"/>
+          </a:xfrm>
+          <a:prstGeom prst="rect">
+            <a:avLst/>
+          </a:prstGeom>
+          <a:noFill/>
+        </p:spPr>
+        <p:txBody>
+          <a:bodyPr wrap="none" rtlCol="0">
+            <a:spAutoFit/>
+          </a:bodyPr>
+          <a:lstStyle/>
+          <a:p>
+            <a:r>
+              <a:rPr lang="en-US" altLang="ja-JP" sz="2400" b="1" dirty="0"/>
+              <a:t>/km</a:t>
+            </a:r>
+            <a:endParaRPr kumimoji="1" lang="ja-JP" altLang="en-US" sz="2400" b="1"/>
+          </a:p>
+        </p:txBody>
+      </p:sp>
+      <p:sp>
+        <p:nvSpPr>
+          <p:cNvPr id="11" name="テキスト ボックス 10">
+            <a:extLst>
+              <a:ext uri="{FF2B5EF4-FFF2-40B4-BE49-F238E27FC236}">
+                <a16:creationId xmlns:a16="http://schemas.microsoft.com/office/drawing/2014/main" id="{B794F263-9DA8-F1B1-A7CC-C902BF7D5A9A}"/>
+              </a:ext>
+            </a:extLst>
+          </p:cNvPr>
+          <p:cNvSpPr txBox="1"/>
+          <p:nvPr/>
+        </p:nvSpPr>
+        <p:spPr>
+          <a:xfrm>
+            <a:off x="3782545" y="3924086"/>
+            <a:ext cx="2113079" cy="707886"/>
+          </a:xfrm>
+          <a:prstGeom prst="rect">
+            <a:avLst/>
+          </a:prstGeom>
+          <a:noFill/>
+        </p:spPr>
+        <p:txBody>
+          <a:bodyPr wrap="none" rtlCol="0">
+            <a:spAutoFit/>
+          </a:bodyPr>
+          <a:lstStyle/>
+          <a:p>
+            <a:r>
+              <a:rPr lang="en-US" altLang="ja-JP" sz="4000" b="1" dirty="0"/>
+              <a:t>22.3 km</a:t>
+            </a:r>
+            <a:endParaRPr kumimoji="1" lang="ja-JP" altLang="en-US" sz="4000" b="1"/>
+          </a:p>
+        </p:txBody>
+      </p:sp>
+      <p:sp>
+        <p:nvSpPr>
+          <p:cNvPr id="12" name="テキスト ボックス 11">
+            <a:extLst>
+              <a:ext uri="{FF2B5EF4-FFF2-40B4-BE49-F238E27FC236}">
+                <a16:creationId xmlns:a16="http://schemas.microsoft.com/office/drawing/2014/main" id="{1621FF95-D906-081E-436D-978407CFE876}"/>
+              </a:ext>
+            </a:extLst>
+          </p:cNvPr>
+          <p:cNvSpPr txBox="1"/>
+          <p:nvPr/>
+        </p:nvSpPr>
+        <p:spPr>
+          <a:xfrm>
+            <a:off x="4819203" y="5162356"/>
+            <a:ext cx="2335896" cy="523220"/>
+          </a:xfrm>
+          <a:prstGeom prst="rect">
+            <a:avLst/>
+          </a:prstGeom>
+          <a:noFill/>
+        </p:spPr>
+        <p:txBody>
+          <a:bodyPr wrap="none" rtlCol="0">
+            <a:spAutoFit/>
+          </a:bodyPr>
+          <a:lstStyle/>
+          <a:p>
+            <a:r>
+              <a:rPr lang="en-US" altLang="ja-JP" sz="2800" b="1" dirty="0"/>
+              <a:t>4:00 (+10</a:t>
+            </a:r>
+            <a:r>
+              <a:rPr lang="ja-JP" altLang="en-US" sz="2800" b="1"/>
+              <a:t>分</a:t>
+            </a:r>
+            <a:r>
+              <a:rPr lang="en-US" altLang="ja-JP" sz="2800" b="1" dirty="0"/>
+              <a:t>)</a:t>
+            </a:r>
+            <a:endParaRPr kumimoji="1" lang="ja-JP" altLang="en-US" sz="2800" b="1"/>
+          </a:p>
+        </p:txBody>
+      </p:sp>
+      <p:cxnSp>
+        <p:nvCxnSpPr>
+          <p:cNvPr id="20" name="直線コネクタ 19">
+            <a:extLst>
+              <a:ext uri="{FF2B5EF4-FFF2-40B4-BE49-F238E27FC236}">
+                <a16:creationId xmlns:a16="http://schemas.microsoft.com/office/drawing/2014/main" id="{93FC0F93-002F-7449-77AC-D30AD688CB33}"/>
+              </a:ext>
+            </a:extLst>
+          </p:cNvPr>
+          <p:cNvCxnSpPr>
+            <a:cxnSpLocks/>
+          </p:cNvCxnSpPr>
+          <p:nvPr/>
+        </p:nvCxnSpPr>
+        <p:spPr>
+          <a:xfrm>
+            <a:off x="2508456" y="4878722"/>
+            <a:ext cx="6957391" cy="27514"/>
+          </a:xfrm>
+          <a:prstGeom prst="line">
+            <a:avLst/>
+          </a:prstGeom>
+        </p:spPr>
+        <p:style>
+          <a:lnRef idx="2">
+            <a:schemeClr val="accent1"/>
+          </a:lnRef>
+          <a:fillRef idx="0">
+            <a:schemeClr val="accent1"/>
+          </a:fillRef>
+          <a:effectRef idx="1">
+            <a:schemeClr val="accent1"/>
+          </a:effectRef>
+          <a:fontRef idx="minor">
+            <a:schemeClr val="tx1"/>
+          </a:fontRef>
+        </p:style>
+      </p:cxnSp>
+      <p:cxnSp>
+        <p:nvCxnSpPr>
+          <p:cNvPr id="21" name="直線コネクタ 20">
+            <a:extLst>
+              <a:ext uri="{FF2B5EF4-FFF2-40B4-BE49-F238E27FC236}">
+                <a16:creationId xmlns:a16="http://schemas.microsoft.com/office/drawing/2014/main" id="{3DAE752E-8656-8985-1DEB-B0988D900784}"/>
+              </a:ext>
+            </a:extLst>
+          </p:cNvPr>
+          <p:cNvCxnSpPr>
+            <a:cxnSpLocks/>
+          </p:cNvCxnSpPr>
+          <p:nvPr/>
+        </p:nvCxnSpPr>
+        <p:spPr>
+          <a:xfrm>
+            <a:off x="2617304" y="2212297"/>
+            <a:ext cx="6957391" cy="27514"/>
+          </a:xfrm>
+          <a:prstGeom prst="line">
+            <a:avLst/>
+          </a:prstGeom>
+        </p:spPr>
+        <p:style>
+          <a:lnRef idx="2">
+            <a:schemeClr val="accent1"/>
+          </a:lnRef>
+          <a:fillRef idx="0">
+            <a:schemeClr val="accent1"/>
+          </a:fillRef>
+          <a:effectRef idx="1">
+            <a:schemeClr val="accent1"/>
+          </a:effectRef>
+          <a:fontRef idx="minor">
+            <a:schemeClr val="tx1"/>
+          </a:fontRef>
+        </p:style>
+      </p:cxnSp>
+      <p:sp>
+        <p:nvSpPr>
+          <p:cNvPr id="6" name="テキスト ボックス 5">
+            <a:extLst>
+              <a:ext uri="{FF2B5EF4-FFF2-40B4-BE49-F238E27FC236}">
+                <a16:creationId xmlns:a16="http://schemas.microsoft.com/office/drawing/2014/main" id="{9D20876A-97A4-B3D5-4631-4D857710D224}"/>
+              </a:ext>
+            </a:extLst>
+          </p:cNvPr>
+          <p:cNvSpPr txBox="1"/>
+          <p:nvPr/>
+        </p:nvSpPr>
+        <p:spPr>
+          <a:xfrm>
+            <a:off x="4858959" y="1125883"/>
+            <a:ext cx="1181734" cy="461665"/>
+          </a:xfrm>
+          <a:prstGeom prst="rect">
+            <a:avLst/>
+          </a:prstGeom>
+          <a:noFill/>
+        </p:spPr>
+        <p:txBody>
+          <a:bodyPr wrap="none" rtlCol="0">
+            <a:spAutoFit/>
+          </a:bodyPr>
+          <a:lstStyle/>
+          <a:p>
+            <a:r>
+              <a:rPr kumimoji="1" lang="en-US" altLang="ja-JP" b="1" dirty="0"/>
+              <a:t>cap </a:t>
+            </a:r>
+            <a:r>
+              <a:rPr kumimoji="1" lang="en-US" altLang="ja-JP" sz="2400" b="1" dirty="0"/>
+              <a:t>155</a:t>
+            </a:r>
+            <a:endParaRPr kumimoji="1" lang="ja-JP" altLang="en-US" b="1"/>
+          </a:p>
+        </p:txBody>
+      </p:sp>
+      <p:sp>
+        <p:nvSpPr>
+          <p:cNvPr id="16" name="正方形/長方形 15">
+            <a:extLst>
+              <a:ext uri="{FF2B5EF4-FFF2-40B4-BE49-F238E27FC236}">
+                <a16:creationId xmlns:a16="http://schemas.microsoft.com/office/drawing/2014/main" id="{6A50901D-8233-EAEF-3924-2BA64638F3F5}"/>
+              </a:ext>
+            </a:extLst>
+          </p:cNvPr>
+          <p:cNvSpPr/>
+          <p:nvPr/>
+        </p:nvSpPr>
+        <p:spPr>
+          <a:xfrm>
+            <a:off x="4007904" y="2434574"/>
+            <a:ext cx="4286807" cy="941783"/>
+          </a:xfrm>
+          <a:prstGeom prst="rect">
+            <a:avLst/>
+          </a:prstGeom>
+          <a:solidFill>
+            <a:schemeClr val="bg1"/>
+          </a:solidFill>
+          <a:ln>
+            <a:noFill/>
+          </a:ln>
+        </p:spPr>
+        <p:style>
+          <a:lnRef idx="2">
+            <a:schemeClr val="accent1">
+              <a:shade val="15000"/>
+            </a:schemeClr>
+          </a:lnRef>
+          <a:fillRef idx="1">
+            <a:schemeClr val="accent1"/>
+          </a:fillRef>
+          <a:effectRef idx="0">
+            <a:schemeClr val="accent1"/>
+          </a:effectRef>
+          <a:fontRef idx="minor">
+            <a:schemeClr val="lt1"/>
+          </a:fontRef>
+        </p:style>
+        <p:txBody>
+          <a:bodyPr rtlCol="0" anchor="ctr"/>
+          <a:lstStyle/>
+          <a:p>
+            <a:pPr algn="ctr"/>
+            <a:r>
+              <a:rPr kumimoji="1" lang="ja-JP" altLang="en-US" sz="4400" b="1">
+                <a:solidFill>
+                  <a:sysClr val="windowText" lastClr="000000"/>
+                </a:solidFill>
+              </a:rPr>
+              <a:t>ちょい落とし</a:t>
+            </a:r>
+          </a:p>
+        </p:txBody>
+      </p:sp>
+      <p:sp>
+        <p:nvSpPr>
+          <p:cNvPr id="7" name="テキスト ボックス 6">
+            <a:extLst>
+              <a:ext uri="{FF2B5EF4-FFF2-40B4-BE49-F238E27FC236}">
+                <a16:creationId xmlns:a16="http://schemas.microsoft.com/office/drawing/2014/main" id="{05A93BED-3489-A7C2-9FA1-DE3110DD6A51}"/>
+              </a:ext>
+            </a:extLst>
+          </p:cNvPr>
+          <p:cNvSpPr txBox="1"/>
+          <p:nvPr/>
+        </p:nvSpPr>
+        <p:spPr>
+          <a:xfrm>
+            <a:off x="6168009" y="3924086"/>
+            <a:ext cx="1965603" cy="707886"/>
+          </a:xfrm>
+          <a:prstGeom prst="rect">
+            <a:avLst/>
+          </a:prstGeom>
+          <a:noFill/>
+        </p:spPr>
+        <p:txBody>
+          <a:bodyPr wrap="none" rtlCol="0">
+            <a:spAutoFit/>
+          </a:bodyPr>
+          <a:lstStyle/>
+          <a:p>
+            <a:r>
+              <a:rPr kumimoji="1" lang="en-US" altLang="ja-JP" sz="4000" b="1" dirty="0"/>
+              <a:t>2:33:12</a:t>
+            </a:r>
+            <a:endParaRPr kumimoji="1" lang="ja-JP" altLang="en-US" sz="4000" b="1"/>
+          </a:p>
+        </p:txBody>
+      </p:sp>
+    </p:spTree>
+    <p:extLst>
+      <p:ext uri="{BB962C8B-B14F-4D97-AF65-F5344CB8AC3E}">
+        <p14:creationId xmlns:p14="http://schemas.microsoft.com/office/powerpoint/2010/main" val="3286036214"/>
+      </p:ext>
+    </p:extLst>
+  </p:cSld>
+  <p:clrMapOvr>
+    <a:masterClrMapping/>
+  </p:clrMapOvr>
+</p:sld>
+</file>
+
+<file path=ppt/slides/slide6.xml><?xml version="1.0" encoding="utf-8"?>
+<p:sld xmlns:a="http://schemas.openxmlformats.org/drawingml/2006/main" xmlns:r="http://schemas.openxmlformats.org/officeDocument/2006/relationships" xmlns:p="http://schemas.openxmlformats.org/presentationml/2006/main">
+  <p:cSld>
+    <p:spTree>
+      <p:nvGrpSpPr>
+        <p:cNvPr id="1" name="">
+          <a:extLst>
+            <a:ext uri="{FF2B5EF4-FFF2-40B4-BE49-F238E27FC236}">
               <a16:creationId xmlns:a16="http://schemas.microsoft.com/office/drawing/2014/main" id="{4A524312-2542-49DA-8C8F-C2544B5EAD8C}"/>
             </a:ext>
           </a:extLst>
@@ -8639,7 +9491,7 @@
 </p:sld>
 </file>
 
-<file path=ppt/slides/slide6.xml><?xml version="1.0" encoding="utf-8"?>
+<file path=ppt/slides/slide7.xml><?xml version="1.0" encoding="utf-8"?>
 <p:sld xmlns:a="http://schemas.openxmlformats.org/drawingml/2006/main" xmlns:r="http://schemas.openxmlformats.org/officeDocument/2006/relationships" xmlns:p="http://schemas.openxmlformats.org/presentationml/2006/main">
   <p:cSld>
     <p:spTree>

</xml_diff>

<commit_message>
Merge remaining local changes (#128)
* Run unit tests by default

* Merge remaining local changes
</commit_message>
<xml_diff>
--- a/assets/モック.pptx
+++ b/assets/モック.pptx
@@ -9,8 +9,9 @@
     <p:sldId id="258" r:id="rId3"/>
     <p:sldId id="259" r:id="rId4"/>
     <p:sldId id="261" r:id="rId5"/>
-    <p:sldId id="257" r:id="rId6"/>
-    <p:sldId id="260" r:id="rId7"/>
+    <p:sldId id="262" r:id="rId6"/>
+    <p:sldId id="257" r:id="rId7"/>
+    <p:sldId id="260" r:id="rId8"/>
   </p:sldIdLst>
   <p:sldSz cx="12192000" cy="6858000"/>
   <p:notesSz cx="6858000" cy="9144000"/>
@@ -264,7 +265,7 @@
           <a:p>
             <a:fld id="{345B8F37-77C0-8845-AC52-CAF113CEA985}" type="datetimeFigureOut">
               <a:rPr kumimoji="1" lang="ja-JP" altLang="en-US" smtClean="0"/>
-              <a:t>2026/3/17</a:t>
+              <a:t>2026/3/21</a:t>
             </a:fld>
             <a:endParaRPr kumimoji="1" lang="ja-JP" altLang="en-US"/>
           </a:p>
@@ -494,7 +495,7 @@
           <a:p>
             <a:fld id="{345B8F37-77C0-8845-AC52-CAF113CEA985}" type="datetimeFigureOut">
               <a:rPr kumimoji="1" lang="ja-JP" altLang="en-US" smtClean="0"/>
-              <a:t>2026/3/17</a:t>
+              <a:t>2026/3/21</a:t>
             </a:fld>
             <a:endParaRPr kumimoji="1" lang="ja-JP" altLang="en-US"/>
           </a:p>
@@ -734,7 +735,7 @@
           <a:p>
             <a:fld id="{345B8F37-77C0-8845-AC52-CAF113CEA985}" type="datetimeFigureOut">
               <a:rPr kumimoji="1" lang="ja-JP" altLang="en-US" smtClean="0"/>
-              <a:t>2026/3/17</a:t>
+              <a:t>2026/3/21</a:t>
             </a:fld>
             <a:endParaRPr kumimoji="1" lang="ja-JP" altLang="en-US"/>
           </a:p>
@@ -964,7 +965,7 @@
           <a:p>
             <a:fld id="{345B8F37-77C0-8845-AC52-CAF113CEA985}" type="datetimeFigureOut">
               <a:rPr kumimoji="1" lang="ja-JP" altLang="en-US" smtClean="0"/>
-              <a:t>2026/3/17</a:t>
+              <a:t>2026/3/21</a:t>
             </a:fld>
             <a:endParaRPr kumimoji="1" lang="ja-JP" altLang="en-US"/>
           </a:p>
@@ -1239,7 +1240,7 @@
           <a:p>
             <a:fld id="{345B8F37-77C0-8845-AC52-CAF113CEA985}" type="datetimeFigureOut">
               <a:rPr kumimoji="1" lang="ja-JP" altLang="en-US" smtClean="0"/>
-              <a:t>2026/3/17</a:t>
+              <a:t>2026/3/21</a:t>
             </a:fld>
             <a:endParaRPr kumimoji="1" lang="ja-JP" altLang="en-US"/>
           </a:p>
@@ -1568,7 +1569,7 @@
           <a:p>
             <a:fld id="{345B8F37-77C0-8845-AC52-CAF113CEA985}" type="datetimeFigureOut">
               <a:rPr kumimoji="1" lang="ja-JP" altLang="en-US" smtClean="0"/>
-              <a:t>2026/3/17</a:t>
+              <a:t>2026/3/21</a:t>
             </a:fld>
             <a:endParaRPr kumimoji="1" lang="ja-JP" altLang="en-US"/>
           </a:p>
@@ -2044,7 +2045,7 @@
           <a:p>
             <a:fld id="{345B8F37-77C0-8845-AC52-CAF113CEA985}" type="datetimeFigureOut">
               <a:rPr kumimoji="1" lang="ja-JP" altLang="en-US" smtClean="0"/>
-              <a:t>2026/3/17</a:t>
+              <a:t>2026/3/21</a:t>
             </a:fld>
             <a:endParaRPr kumimoji="1" lang="ja-JP" altLang="en-US"/>
           </a:p>
@@ -2185,7 +2186,7 @@
           <a:p>
             <a:fld id="{345B8F37-77C0-8845-AC52-CAF113CEA985}" type="datetimeFigureOut">
               <a:rPr kumimoji="1" lang="ja-JP" altLang="en-US" smtClean="0"/>
-              <a:t>2026/3/17</a:t>
+              <a:t>2026/3/21</a:t>
             </a:fld>
             <a:endParaRPr kumimoji="1" lang="ja-JP" altLang="en-US"/>
           </a:p>
@@ -2298,7 +2299,7 @@
           <a:p>
             <a:fld id="{345B8F37-77C0-8845-AC52-CAF113CEA985}" type="datetimeFigureOut">
               <a:rPr kumimoji="1" lang="ja-JP" altLang="en-US" smtClean="0"/>
-              <a:t>2026/3/17</a:t>
+              <a:t>2026/3/21</a:t>
             </a:fld>
             <a:endParaRPr kumimoji="1" lang="ja-JP" altLang="en-US"/>
           </a:p>
@@ -2641,7 +2642,7 @@
           <a:p>
             <a:fld id="{345B8F37-77C0-8845-AC52-CAF113CEA985}" type="datetimeFigureOut">
               <a:rPr kumimoji="1" lang="ja-JP" altLang="en-US" smtClean="0"/>
-              <a:t>2026/3/17</a:t>
+              <a:t>2026/3/21</a:t>
             </a:fld>
             <a:endParaRPr kumimoji="1" lang="ja-JP" altLang="en-US"/>
           </a:p>
@@ -2929,7 +2930,7 @@
           <a:p>
             <a:fld id="{345B8F37-77C0-8845-AC52-CAF113CEA985}" type="datetimeFigureOut">
               <a:rPr kumimoji="1" lang="ja-JP" altLang="en-US" smtClean="0"/>
-              <a:t>2026/3/17</a:t>
+              <a:t>2026/3/21</a:t>
             </a:fld>
             <a:endParaRPr kumimoji="1" lang="ja-JP" altLang="en-US"/>
           </a:p>
@@ -3202,7 +3203,7 @@
           <a:p>
             <a:fld id="{345B8F37-77C0-8845-AC52-CAF113CEA985}" type="datetimeFigureOut">
               <a:rPr kumimoji="1" lang="ja-JP" altLang="en-US" smtClean="0"/>
-              <a:t>2026/3/17</a:t>
+              <a:t>2026/3/21</a:t>
             </a:fld>
             <a:endParaRPr kumimoji="1" lang="ja-JP" altLang="en-US"/>
           </a:p>
@@ -7652,6 +7653,857 @@
         <p:cNvPr id="1" name="">
           <a:extLst>
             <a:ext uri="{FF2B5EF4-FFF2-40B4-BE49-F238E27FC236}">
+              <a16:creationId xmlns:a16="http://schemas.microsoft.com/office/drawing/2014/main" id="{5442CF35-9A69-9D1D-95EC-2EB9B1C6F105}"/>
+            </a:ext>
+          </a:extLst>
+        </p:cNvPr>
+        <p:cNvGrpSpPr/>
+        <p:nvPr/>
+      </p:nvGrpSpPr>
+      <p:grpSpPr>
+        <a:xfrm>
+          <a:off x="0" y="0"/>
+          <a:ext cx="0" cy="0"/>
+          <a:chOff x="0" y="0"/>
+          <a:chExt cx="0" cy="0"/>
+        </a:xfrm>
+      </p:grpSpPr>
+      <p:sp>
+        <p:nvSpPr>
+          <p:cNvPr id="5" name="角丸四角形 4">
+            <a:extLst>
+              <a:ext uri="{FF2B5EF4-FFF2-40B4-BE49-F238E27FC236}">
+                <a16:creationId xmlns:a16="http://schemas.microsoft.com/office/drawing/2014/main" id="{4A2A53C1-EB95-EF1F-4910-C5337F376400}"/>
+              </a:ext>
+            </a:extLst>
+          </p:cNvPr>
+          <p:cNvSpPr/>
+          <p:nvPr/>
+        </p:nvSpPr>
+        <p:spPr>
+          <a:xfrm>
+            <a:off x="3449223" y="2306383"/>
+            <a:ext cx="5437572" cy="1257905"/>
+          </a:xfrm>
+          <a:prstGeom prst="roundRect">
+            <a:avLst/>
+          </a:prstGeom>
+        </p:spPr>
+        <p:style>
+          <a:lnRef idx="2">
+            <a:schemeClr val="accent1">
+              <a:shade val="15000"/>
+            </a:schemeClr>
+          </a:lnRef>
+          <a:fillRef idx="1">
+            <a:schemeClr val="accent1"/>
+          </a:fillRef>
+          <a:effectRef idx="0">
+            <a:schemeClr val="accent1"/>
+          </a:effectRef>
+          <a:fontRef idx="minor">
+            <a:schemeClr val="lt1"/>
+          </a:fontRef>
+        </p:style>
+        <p:txBody>
+          <a:bodyPr rtlCol="0" anchor="ctr"/>
+          <a:lstStyle/>
+          <a:p>
+            <a:pPr algn="ctr"/>
+            <a:r>
+              <a:rPr kumimoji="1" lang="ja-JP" altLang="en-US" sz="3600"/>
+              <a:t>ちょい落とし</a:t>
+            </a:r>
+          </a:p>
+        </p:txBody>
+      </p:sp>
+      <p:sp>
+        <p:nvSpPr>
+          <p:cNvPr id="15" name="正方形/長方形 14">
+            <a:extLst>
+              <a:ext uri="{FF2B5EF4-FFF2-40B4-BE49-F238E27FC236}">
+                <a16:creationId xmlns:a16="http://schemas.microsoft.com/office/drawing/2014/main" id="{827ACAC7-D00E-6220-8A18-807EA52A9AD1}"/>
+              </a:ext>
+            </a:extLst>
+          </p:cNvPr>
+          <p:cNvSpPr/>
+          <p:nvPr/>
+        </p:nvSpPr>
+        <p:spPr>
+          <a:xfrm rot="892720" flipH="1" flipV="1">
+            <a:off x="3085015" y="1975482"/>
+            <a:ext cx="514745" cy="1558521"/>
+          </a:xfrm>
+          <a:prstGeom prst="rect">
+            <a:avLst/>
+          </a:prstGeom>
+          <a:solidFill>
+            <a:schemeClr val="bg1"/>
+          </a:solidFill>
+          <a:ln>
+            <a:noFill/>
+          </a:ln>
+        </p:spPr>
+        <p:style>
+          <a:lnRef idx="2">
+            <a:schemeClr val="accent1">
+              <a:shade val="15000"/>
+            </a:schemeClr>
+          </a:lnRef>
+          <a:fillRef idx="1">
+            <a:schemeClr val="accent1"/>
+          </a:fillRef>
+          <a:effectRef idx="0">
+            <a:schemeClr val="accent1"/>
+          </a:effectRef>
+          <a:fontRef idx="minor">
+            <a:schemeClr val="lt1"/>
+          </a:fontRef>
+        </p:style>
+        <p:txBody>
+          <a:bodyPr rtlCol="0" anchor="ctr"/>
+          <a:lstStyle/>
+          <a:p>
+            <a:pPr algn="ctr"/>
+            <a:endParaRPr kumimoji="1" lang="ja-JP" altLang="en-US"/>
+          </a:p>
+        </p:txBody>
+      </p:sp>
+      <p:sp>
+        <p:nvSpPr>
+          <p:cNvPr id="14" name="正方形/長方形 13">
+            <a:extLst>
+              <a:ext uri="{FF2B5EF4-FFF2-40B4-BE49-F238E27FC236}">
+                <a16:creationId xmlns:a16="http://schemas.microsoft.com/office/drawing/2014/main" id="{5CD8988F-7127-53B5-8BD3-D039C611CB38}"/>
+              </a:ext>
+            </a:extLst>
+          </p:cNvPr>
+          <p:cNvSpPr/>
+          <p:nvPr/>
+        </p:nvSpPr>
+        <p:spPr>
+          <a:xfrm rot="20707280" flipV="1">
+            <a:off x="8637368" y="2171333"/>
+            <a:ext cx="514745" cy="1558521"/>
+          </a:xfrm>
+          <a:prstGeom prst="rect">
+            <a:avLst/>
+          </a:prstGeom>
+          <a:solidFill>
+            <a:schemeClr val="bg1"/>
+          </a:solidFill>
+          <a:ln>
+            <a:noFill/>
+          </a:ln>
+        </p:spPr>
+        <p:style>
+          <a:lnRef idx="2">
+            <a:schemeClr val="accent1">
+              <a:shade val="15000"/>
+            </a:schemeClr>
+          </a:lnRef>
+          <a:fillRef idx="1">
+            <a:schemeClr val="accent1"/>
+          </a:fillRef>
+          <a:effectRef idx="0">
+            <a:schemeClr val="accent1"/>
+          </a:effectRef>
+          <a:fontRef idx="minor">
+            <a:schemeClr val="lt1"/>
+          </a:fontRef>
+        </p:style>
+        <p:txBody>
+          <a:bodyPr rtlCol="0" anchor="ctr"/>
+          <a:lstStyle/>
+          <a:p>
+            <a:pPr algn="ctr"/>
+            <a:endParaRPr kumimoji="1" lang="ja-JP" altLang="en-US"/>
+          </a:p>
+        </p:txBody>
+      </p:sp>
+      <p:sp>
+        <p:nvSpPr>
+          <p:cNvPr id="13" name="ドーナツ 12">
+            <a:extLst>
+              <a:ext uri="{FF2B5EF4-FFF2-40B4-BE49-F238E27FC236}">
+                <a16:creationId xmlns:a16="http://schemas.microsoft.com/office/drawing/2014/main" id="{7F47662C-2F13-872A-F810-7663FEFC6251}"/>
+              </a:ext>
+            </a:extLst>
+          </p:cNvPr>
+          <p:cNvSpPr/>
+          <p:nvPr/>
+        </p:nvSpPr>
+        <p:spPr>
+          <a:xfrm>
+            <a:off x="3396000" y="900113"/>
+            <a:ext cx="5400000" cy="5400000"/>
+          </a:xfrm>
+          <a:prstGeom prst="donut">
+            <a:avLst>
+              <a:gd name="adj" fmla="val 1867"/>
+            </a:avLst>
+          </a:prstGeom>
+          <a:solidFill>
+            <a:schemeClr val="tx1">
+              <a:lumMod val="50000"/>
+              <a:lumOff val="50000"/>
+            </a:schemeClr>
+          </a:solidFill>
+        </p:spPr>
+        <p:style>
+          <a:lnRef idx="2">
+            <a:schemeClr val="accent1">
+              <a:shade val="15000"/>
+            </a:schemeClr>
+          </a:lnRef>
+          <a:fillRef idx="1">
+            <a:schemeClr val="accent1"/>
+          </a:fillRef>
+          <a:effectRef idx="0">
+            <a:schemeClr val="accent1"/>
+          </a:effectRef>
+          <a:fontRef idx="minor">
+            <a:schemeClr val="lt1"/>
+          </a:fontRef>
+        </p:style>
+        <p:txBody>
+          <a:bodyPr rtlCol="0" anchor="ctr"/>
+          <a:lstStyle/>
+          <a:p>
+            <a:pPr algn="ctr"/>
+            <a:endParaRPr kumimoji="1" lang="ja-JP" altLang="en-US">
+              <a:solidFill>
+                <a:schemeClr val="tx1"/>
+              </a:solidFill>
+            </a:endParaRPr>
+          </a:p>
+        </p:txBody>
+      </p:sp>
+      <p:cxnSp>
+        <p:nvCxnSpPr>
+          <p:cNvPr id="17" name="直線コネクタ 16">
+            <a:extLst>
+              <a:ext uri="{FF2B5EF4-FFF2-40B4-BE49-F238E27FC236}">
+                <a16:creationId xmlns:a16="http://schemas.microsoft.com/office/drawing/2014/main" id="{26AF439D-4A39-CEFF-1CA7-7886D9C0CC51}"/>
+              </a:ext>
+            </a:extLst>
+          </p:cNvPr>
+          <p:cNvCxnSpPr>
+            <a:cxnSpLocks/>
+          </p:cNvCxnSpPr>
+          <p:nvPr/>
+        </p:nvCxnSpPr>
+        <p:spPr>
+          <a:xfrm>
+            <a:off x="6096000" y="337930"/>
+            <a:ext cx="0" cy="6520070"/>
+          </a:xfrm>
+          <a:prstGeom prst="line">
+            <a:avLst/>
+          </a:prstGeom>
+        </p:spPr>
+        <p:style>
+          <a:lnRef idx="2">
+            <a:schemeClr val="accent1"/>
+          </a:lnRef>
+          <a:fillRef idx="0">
+            <a:schemeClr val="accent1"/>
+          </a:fillRef>
+          <a:effectRef idx="1">
+            <a:schemeClr val="accent1"/>
+          </a:effectRef>
+          <a:fontRef idx="minor">
+            <a:schemeClr val="tx1"/>
+          </a:fontRef>
+        </p:style>
+      </p:cxnSp>
+      <p:cxnSp>
+        <p:nvCxnSpPr>
+          <p:cNvPr id="23" name="直線コネクタ 22">
+            <a:extLst>
+              <a:ext uri="{FF2B5EF4-FFF2-40B4-BE49-F238E27FC236}">
+                <a16:creationId xmlns:a16="http://schemas.microsoft.com/office/drawing/2014/main" id="{CD203221-8549-C002-E3D4-DAC3AD0830AA}"/>
+              </a:ext>
+            </a:extLst>
+          </p:cNvPr>
+          <p:cNvCxnSpPr>
+            <a:cxnSpLocks/>
+          </p:cNvCxnSpPr>
+          <p:nvPr/>
+        </p:nvCxnSpPr>
+        <p:spPr>
+          <a:xfrm>
+            <a:off x="2484783" y="3632211"/>
+            <a:ext cx="6957391" cy="27514"/>
+          </a:xfrm>
+          <a:prstGeom prst="line">
+            <a:avLst/>
+          </a:prstGeom>
+        </p:spPr>
+        <p:style>
+          <a:lnRef idx="2">
+            <a:schemeClr val="accent1"/>
+          </a:lnRef>
+          <a:fillRef idx="0">
+            <a:schemeClr val="accent1"/>
+          </a:fillRef>
+          <a:effectRef idx="1">
+            <a:schemeClr val="accent1"/>
+          </a:effectRef>
+          <a:fontRef idx="minor">
+            <a:schemeClr val="tx1"/>
+          </a:fontRef>
+        </p:style>
+      </p:cxnSp>
+      <p:sp>
+        <p:nvSpPr>
+          <p:cNvPr id="53" name="テキスト ボックス 52">
+            <a:extLst>
+              <a:ext uri="{FF2B5EF4-FFF2-40B4-BE49-F238E27FC236}">
+                <a16:creationId xmlns:a16="http://schemas.microsoft.com/office/drawing/2014/main" id="{72676624-449C-5992-F924-7AB1D3351774}"/>
+              </a:ext>
+            </a:extLst>
+          </p:cNvPr>
+          <p:cNvSpPr txBox="1"/>
+          <p:nvPr/>
+        </p:nvSpPr>
+        <p:spPr>
+          <a:xfrm>
+            <a:off x="8445904" y="4860375"/>
+            <a:ext cx="341760" cy="369332"/>
+          </a:xfrm>
+          <a:prstGeom prst="rect">
+            <a:avLst/>
+          </a:prstGeom>
+          <a:noFill/>
+        </p:spPr>
+        <p:txBody>
+          <a:bodyPr wrap="square" rtlCol="0">
+            <a:spAutoFit/>
+          </a:bodyPr>
+          <a:lstStyle/>
+          <a:p>
+            <a:r>
+              <a:rPr lang="en-US" altLang="ja-JP" dirty="0"/>
+              <a:t>E</a:t>
+            </a:r>
+            <a:endParaRPr kumimoji="1" lang="ja-JP" altLang="en-US"/>
+          </a:p>
+        </p:txBody>
+      </p:sp>
+      <p:sp>
+        <p:nvSpPr>
+          <p:cNvPr id="67" name="テキスト ボックス 66">
+            <a:extLst>
+              <a:ext uri="{FF2B5EF4-FFF2-40B4-BE49-F238E27FC236}">
+                <a16:creationId xmlns:a16="http://schemas.microsoft.com/office/drawing/2014/main" id="{E678C8CA-A4A9-E37D-69AE-8FB9B3AF3826}"/>
+              </a:ext>
+            </a:extLst>
+          </p:cNvPr>
+          <p:cNvSpPr txBox="1"/>
+          <p:nvPr/>
+        </p:nvSpPr>
+        <p:spPr>
+          <a:xfrm>
+            <a:off x="3035454" y="3429000"/>
+            <a:ext cx="341760" cy="369332"/>
+          </a:xfrm>
+          <a:prstGeom prst="rect">
+            <a:avLst/>
+          </a:prstGeom>
+          <a:noFill/>
+        </p:spPr>
+        <p:txBody>
+          <a:bodyPr wrap="square" rtlCol="0">
+            <a:spAutoFit/>
+          </a:bodyPr>
+          <a:lstStyle/>
+          <a:p>
+            <a:r>
+              <a:rPr lang="en-US" altLang="ja-JP" dirty="0"/>
+              <a:t>J</a:t>
+            </a:r>
+            <a:endParaRPr kumimoji="1" lang="ja-JP" altLang="en-US"/>
+          </a:p>
+        </p:txBody>
+      </p:sp>
+      <p:sp>
+        <p:nvSpPr>
+          <p:cNvPr id="4" name="ハート 3">
+            <a:extLst>
+              <a:ext uri="{FF2B5EF4-FFF2-40B4-BE49-F238E27FC236}">
+                <a16:creationId xmlns:a16="http://schemas.microsoft.com/office/drawing/2014/main" id="{EDBE5130-6299-5FC9-FB6C-F12B6D982EA6}"/>
+              </a:ext>
+            </a:extLst>
+          </p:cNvPr>
+          <p:cNvSpPr/>
+          <p:nvPr/>
+        </p:nvSpPr>
+        <p:spPr>
+          <a:xfrm>
+            <a:off x="4609003" y="1680371"/>
+            <a:ext cx="488696" cy="432040"/>
+          </a:xfrm>
+          <a:prstGeom prst="heart">
+            <a:avLst/>
+          </a:prstGeom>
+          <a:solidFill>
+            <a:schemeClr val="accent3">
+              <a:lumMod val="40000"/>
+              <a:lumOff val="60000"/>
+            </a:schemeClr>
+          </a:solidFill>
+          <a:ln w="38100">
+            <a:solidFill>
+              <a:schemeClr val="accent6"/>
+            </a:solidFill>
+          </a:ln>
+        </p:spPr>
+        <p:style>
+          <a:lnRef idx="2">
+            <a:schemeClr val="accent1">
+              <a:shade val="15000"/>
+            </a:schemeClr>
+          </a:lnRef>
+          <a:fillRef idx="1">
+            <a:schemeClr val="accent1"/>
+          </a:fillRef>
+          <a:effectRef idx="0">
+            <a:schemeClr val="accent1"/>
+          </a:effectRef>
+          <a:fontRef idx="minor">
+            <a:schemeClr val="lt1"/>
+          </a:fontRef>
+        </p:style>
+        <p:txBody>
+          <a:bodyPr rtlCol="0" anchor="ctr"/>
+          <a:lstStyle/>
+          <a:p>
+            <a:pPr algn="ctr"/>
+            <a:endParaRPr kumimoji="1" lang="ja-JP" altLang="en-US"/>
+          </a:p>
+        </p:txBody>
+      </p:sp>
+      <p:sp>
+        <p:nvSpPr>
+          <p:cNvPr id="3" name="テキスト ボックス 2">
+            <a:extLst>
+              <a:ext uri="{FF2B5EF4-FFF2-40B4-BE49-F238E27FC236}">
+                <a16:creationId xmlns:a16="http://schemas.microsoft.com/office/drawing/2014/main" id="{CB912C3D-A750-5FDC-9E75-929E81937DD2}"/>
+              </a:ext>
+            </a:extLst>
+          </p:cNvPr>
+          <p:cNvSpPr txBox="1"/>
+          <p:nvPr/>
+        </p:nvSpPr>
+        <p:spPr>
+          <a:xfrm>
+            <a:off x="5258118" y="1663743"/>
+            <a:ext cx="800219" cy="523220"/>
+          </a:xfrm>
+          <a:prstGeom prst="rect">
+            <a:avLst/>
+          </a:prstGeom>
+          <a:noFill/>
+        </p:spPr>
+        <p:txBody>
+          <a:bodyPr wrap="none" rtlCol="0">
+            <a:spAutoFit/>
+          </a:bodyPr>
+          <a:lstStyle/>
+          <a:p>
+            <a:r>
+              <a:rPr kumimoji="1" lang="en-US" altLang="ja-JP" sz="2800" b="1" dirty="0"/>
+              <a:t>152</a:t>
+            </a:r>
+            <a:endParaRPr kumimoji="1" lang="ja-JP" altLang="en-US" sz="2800" b="1"/>
+          </a:p>
+        </p:txBody>
+      </p:sp>
+      <p:sp>
+        <p:nvSpPr>
+          <p:cNvPr id="9" name="テキスト ボックス 8">
+            <a:extLst>
+              <a:ext uri="{FF2B5EF4-FFF2-40B4-BE49-F238E27FC236}">
+                <a16:creationId xmlns:a16="http://schemas.microsoft.com/office/drawing/2014/main" id="{74D9A41E-BCA6-00DB-FE9E-9C6741AD23EB}"/>
+              </a:ext>
+            </a:extLst>
+          </p:cNvPr>
+          <p:cNvSpPr txBox="1"/>
+          <p:nvPr/>
+        </p:nvSpPr>
+        <p:spPr>
+          <a:xfrm>
+            <a:off x="6151308" y="1434034"/>
+            <a:ext cx="1430200" cy="830997"/>
+          </a:xfrm>
+          <a:prstGeom prst="rect">
+            <a:avLst/>
+          </a:prstGeom>
+          <a:noFill/>
+        </p:spPr>
+        <p:txBody>
+          <a:bodyPr wrap="none" rtlCol="0">
+            <a:spAutoFit/>
+          </a:bodyPr>
+          <a:lstStyle/>
+          <a:p>
+            <a:r>
+              <a:rPr lang="en-US" altLang="ja-JP" sz="4800" b="1" dirty="0"/>
+              <a:t>7:21</a:t>
+            </a:r>
+            <a:endParaRPr kumimoji="1" lang="ja-JP" altLang="en-US" sz="4800" b="1"/>
+          </a:p>
+        </p:txBody>
+      </p:sp>
+      <p:sp>
+        <p:nvSpPr>
+          <p:cNvPr id="10" name="テキスト ボックス 9">
+            <a:extLst>
+              <a:ext uri="{FF2B5EF4-FFF2-40B4-BE49-F238E27FC236}">
+                <a16:creationId xmlns:a16="http://schemas.microsoft.com/office/drawing/2014/main" id="{58E1BB0C-B7AB-461D-2579-9663FBB8FB63}"/>
+              </a:ext>
+            </a:extLst>
+          </p:cNvPr>
+          <p:cNvSpPr txBox="1"/>
+          <p:nvPr/>
+        </p:nvSpPr>
+        <p:spPr>
+          <a:xfrm>
+            <a:off x="7394946" y="1762435"/>
+            <a:ext cx="793807" cy="461665"/>
+          </a:xfrm>
+          <a:prstGeom prst="rect">
+            <a:avLst/>
+          </a:prstGeom>
+          <a:noFill/>
+        </p:spPr>
+        <p:txBody>
+          <a:bodyPr wrap="none" rtlCol="0">
+            <a:spAutoFit/>
+          </a:bodyPr>
+          <a:lstStyle/>
+          <a:p>
+            <a:r>
+              <a:rPr lang="en-US" altLang="ja-JP" sz="2400" b="1" dirty="0"/>
+              <a:t>/km</a:t>
+            </a:r>
+            <a:endParaRPr kumimoji="1" lang="ja-JP" altLang="en-US" sz="2400" b="1"/>
+          </a:p>
+        </p:txBody>
+      </p:sp>
+      <p:sp>
+        <p:nvSpPr>
+          <p:cNvPr id="11" name="テキスト ボックス 10">
+            <a:extLst>
+              <a:ext uri="{FF2B5EF4-FFF2-40B4-BE49-F238E27FC236}">
+                <a16:creationId xmlns:a16="http://schemas.microsoft.com/office/drawing/2014/main" id="{B794F263-9DA8-F1B1-A7CC-C902BF7D5A9A}"/>
+              </a:ext>
+            </a:extLst>
+          </p:cNvPr>
+          <p:cNvSpPr txBox="1"/>
+          <p:nvPr/>
+        </p:nvSpPr>
+        <p:spPr>
+          <a:xfrm>
+            <a:off x="3782545" y="3924086"/>
+            <a:ext cx="2113079" cy="707886"/>
+          </a:xfrm>
+          <a:prstGeom prst="rect">
+            <a:avLst/>
+          </a:prstGeom>
+          <a:noFill/>
+        </p:spPr>
+        <p:txBody>
+          <a:bodyPr wrap="none" rtlCol="0">
+            <a:spAutoFit/>
+          </a:bodyPr>
+          <a:lstStyle/>
+          <a:p>
+            <a:r>
+              <a:rPr lang="en-US" altLang="ja-JP" sz="4000" b="1" dirty="0"/>
+              <a:t>22.3 km</a:t>
+            </a:r>
+            <a:endParaRPr kumimoji="1" lang="ja-JP" altLang="en-US" sz="4000" b="1"/>
+          </a:p>
+        </p:txBody>
+      </p:sp>
+      <p:sp>
+        <p:nvSpPr>
+          <p:cNvPr id="12" name="テキスト ボックス 11">
+            <a:extLst>
+              <a:ext uri="{FF2B5EF4-FFF2-40B4-BE49-F238E27FC236}">
+                <a16:creationId xmlns:a16="http://schemas.microsoft.com/office/drawing/2014/main" id="{1621FF95-D906-081E-436D-978407CFE876}"/>
+              </a:ext>
+            </a:extLst>
+          </p:cNvPr>
+          <p:cNvSpPr txBox="1"/>
+          <p:nvPr/>
+        </p:nvSpPr>
+        <p:spPr>
+          <a:xfrm>
+            <a:off x="4819203" y="5162356"/>
+            <a:ext cx="2335896" cy="523220"/>
+          </a:xfrm>
+          <a:prstGeom prst="rect">
+            <a:avLst/>
+          </a:prstGeom>
+          <a:noFill/>
+        </p:spPr>
+        <p:txBody>
+          <a:bodyPr wrap="none" rtlCol="0">
+            <a:spAutoFit/>
+          </a:bodyPr>
+          <a:lstStyle/>
+          <a:p>
+            <a:r>
+              <a:rPr lang="en-US" altLang="ja-JP" sz="2800" b="1" dirty="0"/>
+              <a:t>4:00 (+10</a:t>
+            </a:r>
+            <a:r>
+              <a:rPr lang="ja-JP" altLang="en-US" sz="2800" b="1"/>
+              <a:t>分</a:t>
+            </a:r>
+            <a:r>
+              <a:rPr lang="en-US" altLang="ja-JP" sz="2800" b="1" dirty="0"/>
+              <a:t>)</a:t>
+            </a:r>
+            <a:endParaRPr kumimoji="1" lang="ja-JP" altLang="en-US" sz="2800" b="1"/>
+          </a:p>
+        </p:txBody>
+      </p:sp>
+      <p:cxnSp>
+        <p:nvCxnSpPr>
+          <p:cNvPr id="20" name="直線コネクタ 19">
+            <a:extLst>
+              <a:ext uri="{FF2B5EF4-FFF2-40B4-BE49-F238E27FC236}">
+                <a16:creationId xmlns:a16="http://schemas.microsoft.com/office/drawing/2014/main" id="{93FC0F93-002F-7449-77AC-D30AD688CB33}"/>
+              </a:ext>
+            </a:extLst>
+          </p:cNvPr>
+          <p:cNvCxnSpPr>
+            <a:cxnSpLocks/>
+          </p:cNvCxnSpPr>
+          <p:nvPr/>
+        </p:nvCxnSpPr>
+        <p:spPr>
+          <a:xfrm>
+            <a:off x="2508456" y="4878722"/>
+            <a:ext cx="6957391" cy="27514"/>
+          </a:xfrm>
+          <a:prstGeom prst="line">
+            <a:avLst/>
+          </a:prstGeom>
+        </p:spPr>
+        <p:style>
+          <a:lnRef idx="2">
+            <a:schemeClr val="accent1"/>
+          </a:lnRef>
+          <a:fillRef idx="0">
+            <a:schemeClr val="accent1"/>
+          </a:fillRef>
+          <a:effectRef idx="1">
+            <a:schemeClr val="accent1"/>
+          </a:effectRef>
+          <a:fontRef idx="minor">
+            <a:schemeClr val="tx1"/>
+          </a:fontRef>
+        </p:style>
+      </p:cxnSp>
+      <p:cxnSp>
+        <p:nvCxnSpPr>
+          <p:cNvPr id="21" name="直線コネクタ 20">
+            <a:extLst>
+              <a:ext uri="{FF2B5EF4-FFF2-40B4-BE49-F238E27FC236}">
+                <a16:creationId xmlns:a16="http://schemas.microsoft.com/office/drawing/2014/main" id="{3DAE752E-8656-8985-1DEB-B0988D900784}"/>
+              </a:ext>
+            </a:extLst>
+          </p:cNvPr>
+          <p:cNvCxnSpPr>
+            <a:cxnSpLocks/>
+          </p:cNvCxnSpPr>
+          <p:nvPr/>
+        </p:nvCxnSpPr>
+        <p:spPr>
+          <a:xfrm>
+            <a:off x="2617304" y="2212297"/>
+            <a:ext cx="6957391" cy="27514"/>
+          </a:xfrm>
+          <a:prstGeom prst="line">
+            <a:avLst/>
+          </a:prstGeom>
+        </p:spPr>
+        <p:style>
+          <a:lnRef idx="2">
+            <a:schemeClr val="accent1"/>
+          </a:lnRef>
+          <a:fillRef idx="0">
+            <a:schemeClr val="accent1"/>
+          </a:fillRef>
+          <a:effectRef idx="1">
+            <a:schemeClr val="accent1"/>
+          </a:effectRef>
+          <a:fontRef idx="minor">
+            <a:schemeClr val="tx1"/>
+          </a:fontRef>
+        </p:style>
+      </p:cxnSp>
+      <p:sp>
+        <p:nvSpPr>
+          <p:cNvPr id="6" name="テキスト ボックス 5">
+            <a:extLst>
+              <a:ext uri="{FF2B5EF4-FFF2-40B4-BE49-F238E27FC236}">
+                <a16:creationId xmlns:a16="http://schemas.microsoft.com/office/drawing/2014/main" id="{9D20876A-97A4-B3D5-4631-4D857710D224}"/>
+              </a:ext>
+            </a:extLst>
+          </p:cNvPr>
+          <p:cNvSpPr txBox="1"/>
+          <p:nvPr/>
+        </p:nvSpPr>
+        <p:spPr>
+          <a:xfrm>
+            <a:off x="4858959" y="1125883"/>
+            <a:ext cx="1181734" cy="461665"/>
+          </a:xfrm>
+          <a:prstGeom prst="rect">
+            <a:avLst/>
+          </a:prstGeom>
+          <a:noFill/>
+        </p:spPr>
+        <p:txBody>
+          <a:bodyPr wrap="none" rtlCol="0">
+            <a:spAutoFit/>
+          </a:bodyPr>
+          <a:lstStyle/>
+          <a:p>
+            <a:r>
+              <a:rPr kumimoji="1" lang="en-US" altLang="ja-JP" b="1" dirty="0"/>
+              <a:t>cap </a:t>
+            </a:r>
+            <a:r>
+              <a:rPr kumimoji="1" lang="en-US" altLang="ja-JP" sz="2400" b="1" dirty="0"/>
+              <a:t>155</a:t>
+            </a:r>
+            <a:endParaRPr kumimoji="1" lang="ja-JP" altLang="en-US" b="1"/>
+          </a:p>
+        </p:txBody>
+      </p:sp>
+      <p:sp>
+        <p:nvSpPr>
+          <p:cNvPr id="16" name="正方形/長方形 15">
+            <a:extLst>
+              <a:ext uri="{FF2B5EF4-FFF2-40B4-BE49-F238E27FC236}">
+                <a16:creationId xmlns:a16="http://schemas.microsoft.com/office/drawing/2014/main" id="{6A50901D-8233-EAEF-3924-2BA64638F3F5}"/>
+              </a:ext>
+            </a:extLst>
+          </p:cNvPr>
+          <p:cNvSpPr/>
+          <p:nvPr/>
+        </p:nvSpPr>
+        <p:spPr>
+          <a:xfrm>
+            <a:off x="4007904" y="2434574"/>
+            <a:ext cx="4286807" cy="941783"/>
+          </a:xfrm>
+          <a:prstGeom prst="rect">
+            <a:avLst/>
+          </a:prstGeom>
+          <a:solidFill>
+            <a:schemeClr val="bg1"/>
+          </a:solidFill>
+          <a:ln>
+            <a:noFill/>
+          </a:ln>
+        </p:spPr>
+        <p:style>
+          <a:lnRef idx="2">
+            <a:schemeClr val="accent1">
+              <a:shade val="15000"/>
+            </a:schemeClr>
+          </a:lnRef>
+          <a:fillRef idx="1">
+            <a:schemeClr val="accent1"/>
+          </a:fillRef>
+          <a:effectRef idx="0">
+            <a:schemeClr val="accent1"/>
+          </a:effectRef>
+          <a:fontRef idx="minor">
+            <a:schemeClr val="lt1"/>
+          </a:fontRef>
+        </p:style>
+        <p:txBody>
+          <a:bodyPr rtlCol="0" anchor="ctr"/>
+          <a:lstStyle/>
+          <a:p>
+            <a:pPr algn="ctr"/>
+            <a:r>
+              <a:rPr kumimoji="1" lang="ja-JP" altLang="en-US" sz="4400" b="1">
+                <a:solidFill>
+                  <a:sysClr val="windowText" lastClr="000000"/>
+                </a:solidFill>
+              </a:rPr>
+              <a:t>ちょい落とし</a:t>
+            </a:r>
+          </a:p>
+        </p:txBody>
+      </p:sp>
+      <p:sp>
+        <p:nvSpPr>
+          <p:cNvPr id="7" name="テキスト ボックス 6">
+            <a:extLst>
+              <a:ext uri="{FF2B5EF4-FFF2-40B4-BE49-F238E27FC236}">
+                <a16:creationId xmlns:a16="http://schemas.microsoft.com/office/drawing/2014/main" id="{05A93BED-3489-A7C2-9FA1-DE3110DD6A51}"/>
+              </a:ext>
+            </a:extLst>
+          </p:cNvPr>
+          <p:cNvSpPr txBox="1"/>
+          <p:nvPr/>
+        </p:nvSpPr>
+        <p:spPr>
+          <a:xfrm>
+            <a:off x="6168009" y="3924086"/>
+            <a:ext cx="1965603" cy="707886"/>
+          </a:xfrm>
+          <a:prstGeom prst="rect">
+            <a:avLst/>
+          </a:prstGeom>
+          <a:noFill/>
+        </p:spPr>
+        <p:txBody>
+          <a:bodyPr wrap="none" rtlCol="0">
+            <a:spAutoFit/>
+          </a:bodyPr>
+          <a:lstStyle/>
+          <a:p>
+            <a:r>
+              <a:rPr kumimoji="1" lang="en-US" altLang="ja-JP" sz="4000" b="1" dirty="0"/>
+              <a:t>2:33:12</a:t>
+            </a:r>
+            <a:endParaRPr kumimoji="1" lang="ja-JP" altLang="en-US" sz="4000" b="1"/>
+          </a:p>
+        </p:txBody>
+      </p:sp>
+    </p:spTree>
+    <p:extLst>
+      <p:ext uri="{BB962C8B-B14F-4D97-AF65-F5344CB8AC3E}">
+        <p14:creationId xmlns:p14="http://schemas.microsoft.com/office/powerpoint/2010/main" val="3286036214"/>
+      </p:ext>
+    </p:extLst>
+  </p:cSld>
+  <p:clrMapOvr>
+    <a:masterClrMapping/>
+  </p:clrMapOvr>
+</p:sld>
+</file>
+
+<file path=ppt/slides/slide6.xml><?xml version="1.0" encoding="utf-8"?>
+<p:sld xmlns:a="http://schemas.openxmlformats.org/drawingml/2006/main" xmlns:r="http://schemas.openxmlformats.org/officeDocument/2006/relationships" xmlns:p="http://schemas.openxmlformats.org/presentationml/2006/main">
+  <p:cSld>
+    <p:spTree>
+      <p:nvGrpSpPr>
+        <p:cNvPr id="1" name="">
+          <a:extLst>
+            <a:ext uri="{FF2B5EF4-FFF2-40B4-BE49-F238E27FC236}">
               <a16:creationId xmlns:a16="http://schemas.microsoft.com/office/drawing/2014/main" id="{4A524312-2542-49DA-8C8F-C2544B5EAD8C}"/>
             </a:ext>
           </a:extLst>
@@ -8639,7 +9491,7 @@
 </p:sld>
 </file>
 
-<file path=ppt/slides/slide6.xml><?xml version="1.0" encoding="utf-8"?>
+<file path=ppt/slides/slide7.xml><?xml version="1.0" encoding="utf-8"?>
 <p:sld xmlns:a="http://schemas.openxmlformats.org/drawingml/2006/main" xmlns:r="http://schemas.openxmlformats.org/officeDocument/2006/relationships" xmlns:p="http://schemas.openxmlformats.org/presentationml/2006/main">
   <p:cSld>
     <p:spTree>

</xml_diff>